<commit_message>
mex city plot and ppt updated
</commit_message>
<xml_diff>
--- a/doc/mexico city trip compa.pptx
+++ b/doc/mexico city trip compa.pptx
@@ -5,7 +5,7 @@
     <p:sldMasterId id="2147483673" r:id="rId1"/>
   </p:sldMasterIdLst>
   <p:notesMasterIdLst>
-    <p:notesMasterId r:id="rId19"/>
+    <p:notesMasterId r:id="rId25"/>
   </p:notesMasterIdLst>
   <p:sldIdLst>
     <p:sldId id="256" r:id="rId2"/>
@@ -25,6 +25,12 @@
     <p:sldId id="270" r:id="rId16"/>
     <p:sldId id="271" r:id="rId17"/>
     <p:sldId id="272" r:id="rId18"/>
+    <p:sldId id="273" r:id="rId19"/>
+    <p:sldId id="274" r:id="rId20"/>
+    <p:sldId id="275" r:id="rId21"/>
+    <p:sldId id="276" r:id="rId22"/>
+    <p:sldId id="277" r:id="rId23"/>
+    <p:sldId id="278" r:id="rId24"/>
   </p:sldIdLst>
   <p:sldSz cx="12192000" cy="6858000"/>
   <p:notesSz cx="6858000" cy="9144000"/>
@@ -213,7 +219,7 @@
           <a:p>
             <a:fld id="{C7149E3F-ECDA-E249-AFAB-866AB257B76A}" type="datetimeFigureOut">
               <a:rPr lang="en-US" smtClean="0"/>
-              <a:t>9/1/25</a:t>
+              <a:t>9/15/25</a:t>
             </a:fld>
             <a:endParaRPr lang="en-US"/>
           </a:p>
@@ -885,7 +891,7 @@
           <a:p>
             <a:fld id="{C128FA71-3A18-48C0-980F-4B68F7F63042}" type="datetime1">
               <a:rPr lang="en-US" smtClean="0"/>
-              <a:t>9/1/25</a:t>
+              <a:t>9/15/25</a:t>
             </a:fld>
             <a:endParaRPr lang="en-US"/>
           </a:p>
@@ -1093,7 +1099,7 @@
           <a:p>
             <a:fld id="{7104EDB3-C0E8-45F8-9E1D-1B6C8D1880C0}" type="datetime1">
               <a:rPr lang="en-US" smtClean="0"/>
-              <a:t>9/1/25</a:t>
+              <a:t>9/15/25</a:t>
             </a:fld>
             <a:endParaRPr lang="en-US"/>
           </a:p>
@@ -1303,7 +1309,7 @@
           <a:p>
             <a:fld id="{9CF0EC4B-54ED-4041-B552-9BA760FA3DBA}" type="datetime1">
               <a:rPr lang="en-US" smtClean="0"/>
-              <a:t>9/1/25</a:t>
+              <a:t>9/15/25</a:t>
             </a:fld>
             <a:endParaRPr lang="en-US"/>
           </a:p>
@@ -1501,7 +1507,7 @@
           <a:p>
             <a:fld id="{51C1210E-201E-4473-82AC-2466F5386C38}" type="datetime1">
               <a:rPr lang="en-US" smtClean="0"/>
-              <a:t>9/1/25</a:t>
+              <a:t>9/15/25</a:t>
             </a:fld>
             <a:endParaRPr lang="en-US"/>
           </a:p>
@@ -1779,7 +1785,7 @@
           <a:p>
             <a:fld id="{B01EA198-6CAB-4B8F-B93F-1F9C8C4B6CE7}" type="datetime1">
               <a:rPr lang="en-US" smtClean="0"/>
-              <a:t>9/1/25</a:t>
+              <a:t>9/15/25</a:t>
             </a:fld>
             <a:endParaRPr lang="en-US"/>
           </a:p>
@@ -2051,7 +2057,7 @@
           <a:p>
             <a:fld id="{CA06041F-4525-44D5-AA4F-332294BF1F56}" type="datetime1">
               <a:rPr lang="en-US" smtClean="0"/>
-              <a:t>9/1/25</a:t>
+              <a:t>9/15/25</a:t>
             </a:fld>
             <a:endParaRPr lang="en-US"/>
           </a:p>
@@ -2475,7 +2481,7 @@
           <a:p>
             <a:fld id="{F9557091-BBDF-4EB9-BA6B-2BB67AC4FC0F}" type="datetime1">
               <a:rPr lang="en-US" smtClean="0"/>
-              <a:t>9/1/25</a:t>
+              <a:t>9/15/25</a:t>
             </a:fld>
             <a:endParaRPr lang="en-US"/>
           </a:p>
@@ -2616,7 +2622,7 @@
           <a:p>
             <a:fld id="{2D6B226B-77A6-410C-9796-083F278E0125}" type="datetime1">
               <a:rPr lang="en-US" smtClean="0"/>
-              <a:t>9/1/25</a:t>
+              <a:t>9/15/25</a:t>
             </a:fld>
             <a:endParaRPr lang="en-US"/>
           </a:p>
@@ -2729,7 +2735,7 @@
           <a:p>
             <a:fld id="{A23A578B-D289-4C40-8593-3D356C49DA58}" type="datetime1">
               <a:rPr lang="en-US" smtClean="0"/>
-              <a:t>9/1/25</a:t>
+              <a:t>9/15/25</a:t>
             </a:fld>
             <a:endParaRPr lang="en-US"/>
           </a:p>
@@ -3048,7 +3054,7 @@
           <a:p>
             <a:fld id="{713DFAE3-14DB-48A7-A80F-80DDB072CE3D}" type="datetime1">
               <a:rPr lang="en-US" smtClean="0"/>
-              <a:t>9/1/25</a:t>
+              <a:t>9/15/25</a:t>
             </a:fld>
             <a:endParaRPr lang="en-US"/>
           </a:p>
@@ -3342,7 +3348,7 @@
           <a:p>
             <a:fld id="{92C5EAEF-6478-4102-8F5D-A5FE9FC97ACB}" type="datetime1">
               <a:rPr lang="en-US" smtClean="0"/>
-              <a:t>9/1/25</a:t>
+              <a:t>9/15/25</a:t>
             </a:fld>
             <a:endParaRPr lang="en-US"/>
           </a:p>
@@ -3583,7 +3589,7 @@
           <a:p>
             <a:fld id="{67F45AC6-C491-4585-A584-9CE2AF7D5500}" type="datetime1">
               <a:rPr lang="en-US" smtClean="0"/>
-              <a:t>9/1/25</a:t>
+              <a:t>9/15/25</a:t>
             </a:fld>
             <a:endParaRPr lang="en-US"/>
           </a:p>
@@ -5848,6 +5854,291 @@
 </p:sld>
 </file>
 
+<file path=ppt/slides/slide18.xml><?xml version="1.0" encoding="utf-8"?>
+<p:sld xmlns:a="http://schemas.openxmlformats.org/drawingml/2006/main" xmlns:r="http://schemas.openxmlformats.org/officeDocument/2006/relationships" xmlns:p="http://schemas.openxmlformats.org/presentationml/2006/main">
+  <p:cSld>
+    <p:spTree>
+      <p:nvGrpSpPr>
+        <p:cNvPr id="1" name=""/>
+        <p:cNvGrpSpPr/>
+        <p:nvPr/>
+      </p:nvGrpSpPr>
+      <p:grpSpPr>
+        <a:xfrm>
+          <a:off x="0" y="0"/>
+          <a:ext cx="0" cy="0"/>
+          <a:chOff x="0" y="0"/>
+          <a:chExt cx="0" cy="0"/>
+        </a:xfrm>
+      </p:grpSpPr>
+      <p:sp>
+        <p:nvSpPr>
+          <p:cNvPr id="2" name="Title 1">
+            <a:extLst>
+              <a:ext uri="{FF2B5EF4-FFF2-40B4-BE49-F238E27FC236}">
+                <a16:creationId xmlns:a16="http://schemas.microsoft.com/office/drawing/2014/main" id="{8955F185-667A-A638-B5F8-F4551AFF7CEB}"/>
+              </a:ext>
+            </a:extLst>
+          </p:cNvPr>
+          <p:cNvSpPr>
+            <a:spLocks noGrp="1"/>
+          </p:cNvSpPr>
+          <p:nvPr>
+            <p:ph type="title"/>
+          </p:nvPr>
+        </p:nvSpPr>
+        <p:spPr>
+          <a:xfrm>
+            <a:off x="769211" y="2862871"/>
+            <a:ext cx="10653578" cy="1132258"/>
+          </a:xfrm>
+        </p:spPr>
+        <p:txBody>
+          <a:bodyPr/>
+          <a:lstStyle/>
+          <a:p>
+            <a:r>
+              <a:rPr lang="en-US" altLang="zh-CN" dirty="0"/>
+              <a:t>Mexico</a:t>
+            </a:r>
+            <a:r>
+              <a:rPr lang="zh-CN" altLang="en-US" dirty="0"/>
+              <a:t> </a:t>
+            </a:r>
+            <a:r>
+              <a:rPr lang="en-US" altLang="zh-CN" dirty="0"/>
+              <a:t>City</a:t>
+            </a:r>
+            <a:endParaRPr lang="en-US" dirty="0"/>
+          </a:p>
+        </p:txBody>
+      </p:sp>
+    </p:spTree>
+    <p:extLst>
+      <p:ext uri="{BB962C8B-B14F-4D97-AF65-F5344CB8AC3E}">
+        <p14:creationId xmlns:p14="http://schemas.microsoft.com/office/powerpoint/2010/main" val="2037135963"/>
+      </p:ext>
+    </p:extLst>
+  </p:cSld>
+  <p:clrMapOvr>
+    <a:masterClrMapping/>
+  </p:clrMapOvr>
+</p:sld>
+</file>
+
+<file path=ppt/slides/slide19.xml><?xml version="1.0" encoding="utf-8"?>
+<p:sld xmlns:a="http://schemas.openxmlformats.org/drawingml/2006/main" xmlns:r="http://schemas.openxmlformats.org/officeDocument/2006/relationships" xmlns:p="http://schemas.openxmlformats.org/presentationml/2006/main">
+  <p:cSld>
+    <p:bg>
+      <p:bgPr>
+        <a:solidFill>
+          <a:schemeClr val="bg1"/>
+        </a:solidFill>
+        <a:effectLst/>
+      </p:bgPr>
+    </p:bg>
+    <p:spTree>
+      <p:nvGrpSpPr>
+        <p:cNvPr id="1" name=""/>
+        <p:cNvGrpSpPr/>
+        <p:nvPr/>
+      </p:nvGrpSpPr>
+      <p:grpSpPr>
+        <a:xfrm>
+          <a:off x="0" y="0"/>
+          <a:ext cx="0" cy="0"/>
+          <a:chOff x="0" y="0"/>
+          <a:chExt cx="0" cy="0"/>
+        </a:xfrm>
+      </p:grpSpPr>
+      <p:sp>
+        <p:nvSpPr>
+          <p:cNvPr id="12" name="Rectangle 11">
+            <a:extLst>
+              <a:ext uri="{FF2B5EF4-FFF2-40B4-BE49-F238E27FC236}">
+                <a16:creationId xmlns:a16="http://schemas.microsoft.com/office/drawing/2014/main" id="{35A92A98-187D-1D81-86FD-8D40CC69B622}"/>
+              </a:ext>
+              <a:ext uri="{C183D7F6-B498-43B3-948B-1728B52AA6E4}">
+                <adec:decorative xmlns:adec="http://schemas.microsoft.com/office/drawing/2017/decorative" val="1"/>
+              </a:ext>
+            </a:extLst>
+          </p:cNvPr>
+          <p:cNvSpPr>
+            <a:spLocks noGrp="1" noRot="1" noChangeAspect="1" noMove="1" noResize="1" noEditPoints="1" noAdjustHandles="1" noChangeArrowheads="1" noChangeShapeType="1" noTextEdit="1"/>
+          </p:cNvSpPr>
+          <p:nvPr>
+            <p:extLst>
+              <p:ext uri="{386F3935-93C4-4BCD-93E2-E3B085C9AB24}">
+                <p16:designElem xmlns:p16="http://schemas.microsoft.com/office/powerpoint/2015/main" val="1"/>
+              </p:ext>
+            </p:extLst>
+          </p:nvPr>
+        </p:nvSpPr>
+        <p:spPr>
+          <a:xfrm>
+            <a:off x="0" y="0"/>
+            <a:ext cx="12192000" cy="6858000"/>
+          </a:xfrm>
+          <a:prstGeom prst="rect">
+            <a:avLst/>
+          </a:prstGeom>
+          <a:solidFill>
+            <a:schemeClr val="bg1"/>
+          </a:solidFill>
+          <a:ln w="12700" cap="flat" cmpd="sng" algn="ctr">
+            <a:noFill/>
+            <a:prstDash val="solid"/>
+            <a:miter lim="800000"/>
+          </a:ln>
+          <a:effectLst/>
+          <a:extLst>
+            <a:ext uri="{91240B29-F687-4F45-9708-019B960494DF}">
+              <a14:hiddenLine xmlns:a14="http://schemas.microsoft.com/office/drawing/2010/main" w="12700" cap="flat" cmpd="sng" algn="ctr">
+                <a:solidFill>
+                  <a:schemeClr val="accent1">
+                    <a:shade val="15000"/>
+                  </a:schemeClr>
+                </a:solidFill>
+                <a:prstDash val="solid"/>
+                <a:miter lim="800000"/>
+              </a14:hiddenLine>
+            </a:ext>
+          </a:extLst>
+        </p:spPr>
+        <p:style>
+          <a:lnRef idx="2">
+            <a:schemeClr val="accent1">
+              <a:shade val="15000"/>
+            </a:schemeClr>
+          </a:lnRef>
+          <a:fillRef idx="1">
+            <a:schemeClr val="accent1"/>
+          </a:fillRef>
+          <a:effectRef idx="0">
+            <a:schemeClr val="accent1"/>
+          </a:effectRef>
+          <a:fontRef idx="minor">
+            <a:schemeClr val="lt1"/>
+          </a:fontRef>
+        </p:style>
+        <p:txBody>
+          <a:bodyPr rtlCol="0" anchor="ctr"/>
+          <a:lstStyle/>
+          <a:p>
+            <a:pPr algn="ctr"/>
+            <a:endParaRPr lang="en-US"/>
+          </a:p>
+        </p:txBody>
+      </p:sp>
+      <p:sp>
+        <p:nvSpPr>
+          <p:cNvPr id="2" name="Title 1">
+            <a:extLst>
+              <a:ext uri="{FF2B5EF4-FFF2-40B4-BE49-F238E27FC236}">
+                <a16:creationId xmlns:a16="http://schemas.microsoft.com/office/drawing/2014/main" id="{93AA7334-5D95-72F7-4931-CB0C72C23336}"/>
+              </a:ext>
+            </a:extLst>
+          </p:cNvPr>
+          <p:cNvSpPr>
+            <a:spLocks noGrp="1"/>
+          </p:cNvSpPr>
+          <p:nvPr>
+            <p:ph type="title"/>
+          </p:nvPr>
+        </p:nvSpPr>
+        <p:spPr>
+          <a:xfrm>
+            <a:off x="492940" y="473829"/>
+            <a:ext cx="11294162" cy="1170252"/>
+          </a:xfrm>
+        </p:spPr>
+        <p:txBody>
+          <a:bodyPr vert="horz" lIns="91440" tIns="45720" rIns="91440" bIns="45720" rtlCol="0" anchor="b">
+            <a:normAutofit/>
+          </a:bodyPr>
+          <a:lstStyle/>
+          <a:p>
+            <a:r>
+              <a:rPr lang="en-US" altLang="zh-CN" sz="4000"/>
+              <a:t>2007 vs 2017 single-trip distribution</a:t>
+            </a:r>
+            <a:endParaRPr lang="en-US" sz="4000"/>
+          </a:p>
+        </p:txBody>
+      </p:sp>
+      <p:pic>
+        <p:nvPicPr>
+          <p:cNvPr id="5" name="Picture 4" descr="A graph with different colored squares&#10;&#10;AI-generated content may be incorrect.">
+            <a:extLst>
+              <a:ext uri="{FF2B5EF4-FFF2-40B4-BE49-F238E27FC236}">
+                <a16:creationId xmlns:a16="http://schemas.microsoft.com/office/drawing/2014/main" id="{4F9AF321-D05F-FCD5-62BC-9353F4492734}"/>
+              </a:ext>
+            </a:extLst>
+          </p:cNvPr>
+          <p:cNvPicPr>
+            <a:picLocks noChangeAspect="1"/>
+          </p:cNvPicPr>
+          <p:nvPr/>
+        </p:nvPicPr>
+        <p:blipFill>
+          <a:blip r:embed="rId2"/>
+          <a:stretch>
+            <a:fillRect/>
+          </a:stretch>
+        </p:blipFill>
+        <p:spPr>
+          <a:xfrm>
+            <a:off x="897486" y="1778654"/>
+            <a:ext cx="5155006" cy="3840480"/>
+          </a:xfrm>
+          <a:prstGeom prst="rect">
+            <a:avLst/>
+          </a:prstGeom>
+        </p:spPr>
+      </p:pic>
+      <p:pic>
+        <p:nvPicPr>
+          <p:cNvPr id="7" name="Picture 6" descr="A graph of different colored squares&#10;&#10;AI-generated content may be incorrect.">
+            <a:extLst>
+              <a:ext uri="{FF2B5EF4-FFF2-40B4-BE49-F238E27FC236}">
+                <a16:creationId xmlns:a16="http://schemas.microsoft.com/office/drawing/2014/main" id="{BD3E73DD-7CDF-E3F8-EDED-CD73C53E4B2F}"/>
+              </a:ext>
+            </a:extLst>
+          </p:cNvPr>
+          <p:cNvPicPr>
+            <a:picLocks noChangeAspect="1"/>
+          </p:cNvPicPr>
+          <p:nvPr/>
+        </p:nvPicPr>
+        <p:blipFill>
+          <a:blip r:embed="rId3"/>
+          <a:stretch>
+            <a:fillRect/>
+          </a:stretch>
+        </p:blipFill>
+        <p:spPr>
+          <a:xfrm>
+            <a:off x="6210925" y="1778654"/>
+            <a:ext cx="5155006" cy="3840480"/>
+          </a:xfrm>
+          <a:prstGeom prst="rect">
+            <a:avLst/>
+          </a:prstGeom>
+        </p:spPr>
+      </p:pic>
+    </p:spTree>
+    <p:extLst>
+      <p:ext uri="{BB962C8B-B14F-4D97-AF65-F5344CB8AC3E}">
+        <p14:creationId xmlns:p14="http://schemas.microsoft.com/office/powerpoint/2010/main" val="3281045255"/>
+      </p:ext>
+    </p:extLst>
+  </p:cSld>
+  <p:clrMapOvr>
+    <a:masterClrMapping/>
+  </p:clrMapOvr>
+</p:sld>
+</file>
+
 <file path=ppt/slides/slide2.xml><?xml version="1.0" encoding="utf-8"?>
 <p:sld xmlns:a="http://schemas.openxmlformats.org/drawingml/2006/main" xmlns:r="http://schemas.openxmlformats.org/officeDocument/2006/relationships" xmlns:p="http://schemas.openxmlformats.org/presentationml/2006/main">
   <p:cSld>
@@ -5958,6 +6249,858 @@
     <p:extLst>
       <p:ext uri="{BB962C8B-B14F-4D97-AF65-F5344CB8AC3E}">
         <p14:creationId xmlns:p14="http://schemas.microsoft.com/office/powerpoint/2010/main" val="321493621"/>
+      </p:ext>
+    </p:extLst>
+  </p:cSld>
+  <p:clrMapOvr>
+    <a:masterClrMapping/>
+  </p:clrMapOvr>
+</p:sld>
+</file>
+
+<file path=ppt/slides/slide20.xml><?xml version="1.0" encoding="utf-8"?>
+<p:sld xmlns:a="http://schemas.openxmlformats.org/drawingml/2006/main" xmlns:r="http://schemas.openxmlformats.org/officeDocument/2006/relationships" xmlns:p="http://schemas.openxmlformats.org/presentationml/2006/main">
+  <p:cSld>
+    <p:bg>
+      <p:bgPr>
+        <a:solidFill>
+          <a:schemeClr val="bg1"/>
+        </a:solidFill>
+        <a:effectLst/>
+      </p:bgPr>
+    </p:bg>
+    <p:spTree>
+      <p:nvGrpSpPr>
+        <p:cNvPr id="1" name=""/>
+        <p:cNvGrpSpPr/>
+        <p:nvPr/>
+      </p:nvGrpSpPr>
+      <p:grpSpPr>
+        <a:xfrm>
+          <a:off x="0" y="0"/>
+          <a:ext cx="0" cy="0"/>
+          <a:chOff x="0" y="0"/>
+          <a:chExt cx="0" cy="0"/>
+        </a:xfrm>
+      </p:grpSpPr>
+      <p:sp>
+        <p:nvSpPr>
+          <p:cNvPr id="12" name="Rectangle 11">
+            <a:extLst>
+              <a:ext uri="{FF2B5EF4-FFF2-40B4-BE49-F238E27FC236}">
+                <a16:creationId xmlns:a16="http://schemas.microsoft.com/office/drawing/2014/main" id="{35A92A98-187D-1D81-86FD-8D40CC69B622}"/>
+              </a:ext>
+              <a:ext uri="{C183D7F6-B498-43B3-948B-1728B52AA6E4}">
+                <adec:decorative xmlns:adec="http://schemas.microsoft.com/office/drawing/2017/decorative" val="1"/>
+              </a:ext>
+            </a:extLst>
+          </p:cNvPr>
+          <p:cNvSpPr>
+            <a:spLocks noGrp="1" noRot="1" noChangeAspect="1" noMove="1" noResize="1" noEditPoints="1" noAdjustHandles="1" noChangeArrowheads="1" noChangeShapeType="1" noTextEdit="1"/>
+          </p:cNvSpPr>
+          <p:nvPr>
+            <p:extLst>
+              <p:ext uri="{386F3935-93C4-4BCD-93E2-E3B085C9AB24}">
+                <p16:designElem xmlns:p16="http://schemas.microsoft.com/office/powerpoint/2015/main" val="1"/>
+              </p:ext>
+            </p:extLst>
+          </p:nvPr>
+        </p:nvSpPr>
+        <p:spPr>
+          <a:xfrm>
+            <a:off x="0" y="0"/>
+            <a:ext cx="12192000" cy="6858000"/>
+          </a:xfrm>
+          <a:prstGeom prst="rect">
+            <a:avLst/>
+          </a:prstGeom>
+          <a:solidFill>
+            <a:schemeClr val="bg1"/>
+          </a:solidFill>
+          <a:ln w="12700" cap="flat" cmpd="sng" algn="ctr">
+            <a:noFill/>
+            <a:prstDash val="solid"/>
+            <a:miter lim="800000"/>
+          </a:ln>
+          <a:effectLst/>
+          <a:extLst>
+            <a:ext uri="{91240B29-F687-4F45-9708-019B960494DF}">
+              <a14:hiddenLine xmlns:a14="http://schemas.microsoft.com/office/drawing/2010/main" w="12700" cap="flat" cmpd="sng" algn="ctr">
+                <a:solidFill>
+                  <a:schemeClr val="accent1">
+                    <a:shade val="15000"/>
+                  </a:schemeClr>
+                </a:solidFill>
+                <a:prstDash val="solid"/>
+                <a:miter lim="800000"/>
+              </a14:hiddenLine>
+            </a:ext>
+          </a:extLst>
+        </p:spPr>
+        <p:style>
+          <a:lnRef idx="2">
+            <a:schemeClr val="accent1">
+              <a:shade val="15000"/>
+            </a:schemeClr>
+          </a:lnRef>
+          <a:fillRef idx="1">
+            <a:schemeClr val="accent1"/>
+          </a:fillRef>
+          <a:effectRef idx="0">
+            <a:schemeClr val="accent1"/>
+          </a:effectRef>
+          <a:fontRef idx="minor">
+            <a:schemeClr val="lt1"/>
+          </a:fontRef>
+        </p:style>
+        <p:txBody>
+          <a:bodyPr rtlCol="0" anchor="ctr"/>
+          <a:lstStyle/>
+          <a:p>
+            <a:pPr algn="ctr"/>
+            <a:endParaRPr lang="en-US"/>
+          </a:p>
+        </p:txBody>
+      </p:sp>
+      <p:sp>
+        <p:nvSpPr>
+          <p:cNvPr id="2" name="Title 1">
+            <a:extLst>
+              <a:ext uri="{FF2B5EF4-FFF2-40B4-BE49-F238E27FC236}">
+                <a16:creationId xmlns:a16="http://schemas.microsoft.com/office/drawing/2014/main" id="{05C1CF67-A555-CA58-F8BE-A363A149B341}"/>
+              </a:ext>
+            </a:extLst>
+          </p:cNvPr>
+          <p:cNvSpPr>
+            <a:spLocks noGrp="1"/>
+          </p:cNvSpPr>
+          <p:nvPr>
+            <p:ph type="title"/>
+          </p:nvPr>
+        </p:nvSpPr>
+        <p:spPr>
+          <a:xfrm>
+            <a:off x="492940" y="473829"/>
+            <a:ext cx="11294162" cy="1170252"/>
+          </a:xfrm>
+        </p:spPr>
+        <p:txBody>
+          <a:bodyPr vert="horz" lIns="91440" tIns="45720" rIns="91440" bIns="45720" rtlCol="0" anchor="b">
+            <a:normAutofit/>
+          </a:bodyPr>
+          <a:lstStyle/>
+          <a:p>
+            <a:r>
+              <a:rPr lang="en-US" altLang="zh-CN" sz="4000"/>
+              <a:t>Metro multimodal trip</a:t>
+            </a:r>
+            <a:endParaRPr lang="en-US" sz="4000"/>
+          </a:p>
+        </p:txBody>
+      </p:sp>
+      <p:pic>
+        <p:nvPicPr>
+          <p:cNvPr id="5" name="Picture 4" descr="A graph with colorful bars&#10;&#10;AI-generated content may be incorrect.">
+            <a:extLst>
+              <a:ext uri="{FF2B5EF4-FFF2-40B4-BE49-F238E27FC236}">
+                <a16:creationId xmlns:a16="http://schemas.microsoft.com/office/drawing/2014/main" id="{C00AB702-4F24-57C8-C646-5C8698F67D2C}"/>
+              </a:ext>
+            </a:extLst>
+          </p:cNvPr>
+          <p:cNvPicPr>
+            <a:picLocks noChangeAspect="1"/>
+          </p:cNvPicPr>
+          <p:nvPr/>
+        </p:nvPicPr>
+        <p:blipFill>
+          <a:blip r:embed="rId2"/>
+          <a:stretch>
+            <a:fillRect/>
+          </a:stretch>
+        </p:blipFill>
+        <p:spPr>
+          <a:xfrm>
+            <a:off x="6181868" y="2086012"/>
+            <a:ext cx="5155006" cy="3840480"/>
+          </a:xfrm>
+          <a:prstGeom prst="rect">
+            <a:avLst/>
+          </a:prstGeom>
+        </p:spPr>
+      </p:pic>
+      <p:pic>
+        <p:nvPicPr>
+          <p:cNvPr id="7" name="Picture 6" descr="A graph with numbers and text&#10;&#10;AI-generated content may be incorrect.">
+            <a:extLst>
+              <a:ext uri="{FF2B5EF4-FFF2-40B4-BE49-F238E27FC236}">
+                <a16:creationId xmlns:a16="http://schemas.microsoft.com/office/drawing/2014/main" id="{5088F7FD-03DB-5359-ACB4-C65128E56CBE}"/>
+              </a:ext>
+            </a:extLst>
+          </p:cNvPr>
+          <p:cNvPicPr>
+            <a:picLocks noChangeAspect="1"/>
+          </p:cNvPicPr>
+          <p:nvPr/>
+        </p:nvPicPr>
+        <p:blipFill>
+          <a:blip r:embed="rId3"/>
+          <a:stretch>
+            <a:fillRect/>
+          </a:stretch>
+        </p:blipFill>
+        <p:spPr>
+          <a:xfrm>
+            <a:off x="607568" y="2117910"/>
+            <a:ext cx="5155006" cy="3840480"/>
+          </a:xfrm>
+          <a:prstGeom prst="rect">
+            <a:avLst/>
+          </a:prstGeom>
+        </p:spPr>
+      </p:pic>
+    </p:spTree>
+    <p:extLst>
+      <p:ext uri="{BB962C8B-B14F-4D97-AF65-F5344CB8AC3E}">
+        <p14:creationId xmlns:p14="http://schemas.microsoft.com/office/powerpoint/2010/main" val="3693666025"/>
+      </p:ext>
+    </p:extLst>
+  </p:cSld>
+  <p:clrMapOvr>
+    <a:masterClrMapping/>
+  </p:clrMapOvr>
+</p:sld>
+</file>
+
+<file path=ppt/slides/slide21.xml><?xml version="1.0" encoding="utf-8"?>
+<p:sld xmlns:a="http://schemas.openxmlformats.org/drawingml/2006/main" xmlns:r="http://schemas.openxmlformats.org/officeDocument/2006/relationships" xmlns:p="http://schemas.openxmlformats.org/presentationml/2006/main">
+  <p:cSld>
+    <p:bg>
+      <p:bgPr>
+        <a:solidFill>
+          <a:schemeClr val="bg1"/>
+        </a:solidFill>
+        <a:effectLst/>
+      </p:bgPr>
+    </p:bg>
+    <p:spTree>
+      <p:nvGrpSpPr>
+        <p:cNvPr id="1" name=""/>
+        <p:cNvGrpSpPr/>
+        <p:nvPr/>
+      </p:nvGrpSpPr>
+      <p:grpSpPr>
+        <a:xfrm>
+          <a:off x="0" y="0"/>
+          <a:ext cx="0" cy="0"/>
+          <a:chOff x="0" y="0"/>
+          <a:chExt cx="0" cy="0"/>
+        </a:xfrm>
+      </p:grpSpPr>
+      <p:sp>
+        <p:nvSpPr>
+          <p:cNvPr id="12" name="Rectangle 11">
+            <a:extLst>
+              <a:ext uri="{FF2B5EF4-FFF2-40B4-BE49-F238E27FC236}">
+                <a16:creationId xmlns:a16="http://schemas.microsoft.com/office/drawing/2014/main" id="{35A92A98-187D-1D81-86FD-8D40CC69B622}"/>
+              </a:ext>
+              <a:ext uri="{C183D7F6-B498-43B3-948B-1728B52AA6E4}">
+                <adec:decorative xmlns:adec="http://schemas.microsoft.com/office/drawing/2017/decorative" val="1"/>
+              </a:ext>
+            </a:extLst>
+          </p:cNvPr>
+          <p:cNvSpPr>
+            <a:spLocks noGrp="1" noRot="1" noChangeAspect="1" noMove="1" noResize="1" noEditPoints="1" noAdjustHandles="1" noChangeArrowheads="1" noChangeShapeType="1" noTextEdit="1"/>
+          </p:cNvSpPr>
+          <p:nvPr>
+            <p:extLst>
+              <p:ext uri="{386F3935-93C4-4BCD-93E2-E3B085C9AB24}">
+                <p16:designElem xmlns:p16="http://schemas.microsoft.com/office/powerpoint/2015/main" val="1"/>
+              </p:ext>
+            </p:extLst>
+          </p:nvPr>
+        </p:nvSpPr>
+        <p:spPr>
+          <a:xfrm>
+            <a:off x="0" y="0"/>
+            <a:ext cx="12192000" cy="6858000"/>
+          </a:xfrm>
+          <a:prstGeom prst="rect">
+            <a:avLst/>
+          </a:prstGeom>
+          <a:solidFill>
+            <a:schemeClr val="bg1"/>
+          </a:solidFill>
+          <a:ln w="12700" cap="flat" cmpd="sng" algn="ctr">
+            <a:noFill/>
+            <a:prstDash val="solid"/>
+            <a:miter lim="800000"/>
+          </a:ln>
+          <a:effectLst/>
+          <a:extLst>
+            <a:ext uri="{91240B29-F687-4F45-9708-019B960494DF}">
+              <a14:hiddenLine xmlns:a14="http://schemas.microsoft.com/office/drawing/2010/main" w="12700" cap="flat" cmpd="sng" algn="ctr">
+                <a:solidFill>
+                  <a:schemeClr val="accent1">
+                    <a:shade val="15000"/>
+                  </a:schemeClr>
+                </a:solidFill>
+                <a:prstDash val="solid"/>
+                <a:miter lim="800000"/>
+              </a14:hiddenLine>
+            </a:ext>
+          </a:extLst>
+        </p:spPr>
+        <p:style>
+          <a:lnRef idx="2">
+            <a:schemeClr val="accent1">
+              <a:shade val="15000"/>
+            </a:schemeClr>
+          </a:lnRef>
+          <a:fillRef idx="1">
+            <a:schemeClr val="accent1"/>
+          </a:fillRef>
+          <a:effectRef idx="0">
+            <a:schemeClr val="accent1"/>
+          </a:effectRef>
+          <a:fontRef idx="minor">
+            <a:schemeClr val="lt1"/>
+          </a:fontRef>
+        </p:style>
+        <p:txBody>
+          <a:bodyPr rtlCol="0" anchor="ctr"/>
+          <a:lstStyle/>
+          <a:p>
+            <a:pPr algn="ctr"/>
+            <a:endParaRPr lang="en-US"/>
+          </a:p>
+        </p:txBody>
+      </p:sp>
+      <p:sp>
+        <p:nvSpPr>
+          <p:cNvPr id="2" name="Title 1">
+            <a:extLst>
+              <a:ext uri="{FF2B5EF4-FFF2-40B4-BE49-F238E27FC236}">
+                <a16:creationId xmlns:a16="http://schemas.microsoft.com/office/drawing/2014/main" id="{A0FD10A5-FEEB-40F7-F2C8-F25974EA11FB}"/>
+              </a:ext>
+            </a:extLst>
+          </p:cNvPr>
+          <p:cNvSpPr>
+            <a:spLocks noGrp="1"/>
+          </p:cNvSpPr>
+          <p:nvPr>
+            <p:ph type="title"/>
+          </p:nvPr>
+        </p:nvSpPr>
+        <p:spPr>
+          <a:xfrm>
+            <a:off x="492940" y="473829"/>
+            <a:ext cx="11294162" cy="1170252"/>
+          </a:xfrm>
+        </p:spPr>
+        <p:txBody>
+          <a:bodyPr vert="horz" lIns="91440" tIns="45720" rIns="91440" bIns="45720" rtlCol="0" anchor="b">
+            <a:normAutofit/>
+          </a:bodyPr>
+          <a:lstStyle/>
+          <a:p>
+            <a:r>
+              <a:rPr lang="en-US" altLang="zh-CN" sz="4000"/>
+              <a:t>BRT Multimodal trip</a:t>
+            </a:r>
+            <a:endParaRPr lang="en-US" sz="4000"/>
+          </a:p>
+        </p:txBody>
+      </p:sp>
+      <p:pic>
+        <p:nvPicPr>
+          <p:cNvPr id="7" name="Picture 6" descr="A graph with a yellow rectangle and blue squares&#10;&#10;AI-generated content may be incorrect.">
+            <a:extLst>
+              <a:ext uri="{FF2B5EF4-FFF2-40B4-BE49-F238E27FC236}">
+                <a16:creationId xmlns:a16="http://schemas.microsoft.com/office/drawing/2014/main" id="{CEBF3803-C336-F4A2-A986-8239B00BA5DC}"/>
+              </a:ext>
+            </a:extLst>
+          </p:cNvPr>
+          <p:cNvPicPr>
+            <a:picLocks noChangeAspect="1"/>
+          </p:cNvPicPr>
+          <p:nvPr/>
+        </p:nvPicPr>
+        <p:blipFill>
+          <a:blip r:embed="rId2"/>
+          <a:stretch>
+            <a:fillRect/>
+          </a:stretch>
+        </p:blipFill>
+        <p:spPr>
+          <a:xfrm>
+            <a:off x="6383886" y="1768022"/>
+            <a:ext cx="5155006" cy="3840480"/>
+          </a:xfrm>
+          <a:prstGeom prst="rect">
+            <a:avLst/>
+          </a:prstGeom>
+        </p:spPr>
+      </p:pic>
+      <p:pic>
+        <p:nvPicPr>
+          <p:cNvPr id="5" name="Picture 4" descr="A graph with a bar graph&#10;&#10;AI-generated content may be incorrect.">
+            <a:extLst>
+              <a:ext uri="{FF2B5EF4-FFF2-40B4-BE49-F238E27FC236}">
+                <a16:creationId xmlns:a16="http://schemas.microsoft.com/office/drawing/2014/main" id="{5101517C-F787-3FF0-2067-BF183D869974}"/>
+              </a:ext>
+            </a:extLst>
+          </p:cNvPr>
+          <p:cNvPicPr>
+            <a:picLocks noChangeAspect="1"/>
+          </p:cNvPicPr>
+          <p:nvPr/>
+        </p:nvPicPr>
+        <p:blipFill>
+          <a:blip r:embed="rId3"/>
+          <a:stretch>
+            <a:fillRect/>
+          </a:stretch>
+        </p:blipFill>
+        <p:spPr>
+          <a:xfrm>
+            <a:off x="1228880" y="1768022"/>
+            <a:ext cx="5155006" cy="3840480"/>
+          </a:xfrm>
+          <a:prstGeom prst="rect">
+            <a:avLst/>
+          </a:prstGeom>
+        </p:spPr>
+      </p:pic>
+    </p:spTree>
+    <p:extLst>
+      <p:ext uri="{BB962C8B-B14F-4D97-AF65-F5344CB8AC3E}">
+        <p14:creationId xmlns:p14="http://schemas.microsoft.com/office/powerpoint/2010/main" val="3178280181"/>
+      </p:ext>
+    </p:extLst>
+  </p:cSld>
+  <p:clrMapOvr>
+    <a:masterClrMapping/>
+  </p:clrMapOvr>
+</p:sld>
+</file>
+
+<file path=ppt/slides/slide22.xml><?xml version="1.0" encoding="utf-8"?>
+<p:sld xmlns:a="http://schemas.openxmlformats.org/drawingml/2006/main" xmlns:r="http://schemas.openxmlformats.org/officeDocument/2006/relationships" xmlns:p="http://schemas.openxmlformats.org/presentationml/2006/main">
+  <p:cSld>
+    <p:bg>
+      <p:bgPr>
+        <a:solidFill>
+          <a:schemeClr val="bg1"/>
+        </a:solidFill>
+        <a:effectLst/>
+      </p:bgPr>
+    </p:bg>
+    <p:spTree>
+      <p:nvGrpSpPr>
+        <p:cNvPr id="1" name=""/>
+        <p:cNvGrpSpPr/>
+        <p:nvPr/>
+      </p:nvGrpSpPr>
+      <p:grpSpPr>
+        <a:xfrm>
+          <a:off x="0" y="0"/>
+          <a:ext cx="0" cy="0"/>
+          <a:chOff x="0" y="0"/>
+          <a:chExt cx="0" cy="0"/>
+        </a:xfrm>
+      </p:grpSpPr>
+      <p:sp>
+        <p:nvSpPr>
+          <p:cNvPr id="12" name="Rectangle 11">
+            <a:extLst>
+              <a:ext uri="{FF2B5EF4-FFF2-40B4-BE49-F238E27FC236}">
+                <a16:creationId xmlns:a16="http://schemas.microsoft.com/office/drawing/2014/main" id="{35A92A98-187D-1D81-86FD-8D40CC69B622}"/>
+              </a:ext>
+              <a:ext uri="{C183D7F6-B498-43B3-948B-1728B52AA6E4}">
+                <adec:decorative xmlns:adec="http://schemas.microsoft.com/office/drawing/2017/decorative" val="1"/>
+              </a:ext>
+            </a:extLst>
+          </p:cNvPr>
+          <p:cNvSpPr>
+            <a:spLocks noGrp="1" noRot="1" noChangeAspect="1" noMove="1" noResize="1" noEditPoints="1" noAdjustHandles="1" noChangeArrowheads="1" noChangeShapeType="1" noTextEdit="1"/>
+          </p:cNvSpPr>
+          <p:nvPr>
+            <p:extLst>
+              <p:ext uri="{386F3935-93C4-4BCD-93E2-E3B085C9AB24}">
+                <p16:designElem xmlns:p16="http://schemas.microsoft.com/office/powerpoint/2015/main" val="1"/>
+              </p:ext>
+            </p:extLst>
+          </p:nvPr>
+        </p:nvSpPr>
+        <p:spPr>
+          <a:xfrm>
+            <a:off x="0" y="0"/>
+            <a:ext cx="12192000" cy="6858000"/>
+          </a:xfrm>
+          <a:prstGeom prst="rect">
+            <a:avLst/>
+          </a:prstGeom>
+          <a:solidFill>
+            <a:schemeClr val="bg1"/>
+          </a:solidFill>
+          <a:ln w="12700" cap="flat" cmpd="sng" algn="ctr">
+            <a:noFill/>
+            <a:prstDash val="solid"/>
+            <a:miter lim="800000"/>
+          </a:ln>
+          <a:effectLst/>
+          <a:extLst>
+            <a:ext uri="{91240B29-F687-4F45-9708-019B960494DF}">
+              <a14:hiddenLine xmlns:a14="http://schemas.microsoft.com/office/drawing/2010/main" w="12700" cap="flat" cmpd="sng" algn="ctr">
+                <a:solidFill>
+                  <a:schemeClr val="accent1">
+                    <a:shade val="15000"/>
+                  </a:schemeClr>
+                </a:solidFill>
+                <a:prstDash val="solid"/>
+                <a:miter lim="800000"/>
+              </a14:hiddenLine>
+            </a:ext>
+          </a:extLst>
+        </p:spPr>
+        <p:style>
+          <a:lnRef idx="2">
+            <a:schemeClr val="accent1">
+              <a:shade val="15000"/>
+            </a:schemeClr>
+          </a:lnRef>
+          <a:fillRef idx="1">
+            <a:schemeClr val="accent1"/>
+          </a:fillRef>
+          <a:effectRef idx="0">
+            <a:schemeClr val="accent1"/>
+          </a:effectRef>
+          <a:fontRef idx="minor">
+            <a:schemeClr val="lt1"/>
+          </a:fontRef>
+        </p:style>
+        <p:txBody>
+          <a:bodyPr rtlCol="0" anchor="ctr"/>
+          <a:lstStyle/>
+          <a:p>
+            <a:pPr algn="ctr"/>
+            <a:endParaRPr lang="en-US"/>
+          </a:p>
+        </p:txBody>
+      </p:sp>
+      <p:sp>
+        <p:nvSpPr>
+          <p:cNvPr id="2" name="Title 1">
+            <a:extLst>
+              <a:ext uri="{FF2B5EF4-FFF2-40B4-BE49-F238E27FC236}">
+                <a16:creationId xmlns:a16="http://schemas.microsoft.com/office/drawing/2014/main" id="{0764EFB2-B975-FA19-150C-704385641B83}"/>
+              </a:ext>
+            </a:extLst>
+          </p:cNvPr>
+          <p:cNvSpPr>
+            <a:spLocks noGrp="1"/>
+          </p:cNvSpPr>
+          <p:nvPr>
+            <p:ph type="title"/>
+          </p:nvPr>
+        </p:nvSpPr>
+        <p:spPr>
+          <a:xfrm>
+            <a:off x="492940" y="473829"/>
+            <a:ext cx="11294162" cy="1170252"/>
+          </a:xfrm>
+        </p:spPr>
+        <p:txBody>
+          <a:bodyPr vert="horz" lIns="91440" tIns="45720" rIns="91440" bIns="45720" rtlCol="0" anchor="b">
+            <a:normAutofit/>
+          </a:bodyPr>
+          <a:lstStyle/>
+          <a:p>
+            <a:r>
+              <a:rPr lang="en-US" altLang="zh-CN" sz="4000"/>
+              <a:t>Bus trip</a:t>
+            </a:r>
+            <a:endParaRPr lang="en-US" sz="4000"/>
+          </a:p>
+        </p:txBody>
+      </p:sp>
+      <p:pic>
+        <p:nvPicPr>
+          <p:cNvPr id="5" name="Picture 4" descr="A graph of a number of different colored squares&#10;&#10;AI-generated content may be incorrect.">
+            <a:extLst>
+              <a:ext uri="{FF2B5EF4-FFF2-40B4-BE49-F238E27FC236}">
+                <a16:creationId xmlns:a16="http://schemas.microsoft.com/office/drawing/2014/main" id="{F5B172DE-A54B-9862-9B48-4D433C388B77}"/>
+              </a:ext>
+            </a:extLst>
+          </p:cNvPr>
+          <p:cNvPicPr>
+            <a:picLocks noChangeAspect="1"/>
+          </p:cNvPicPr>
+          <p:nvPr/>
+        </p:nvPicPr>
+        <p:blipFill>
+          <a:blip r:embed="rId2"/>
+          <a:stretch>
+            <a:fillRect/>
+          </a:stretch>
+        </p:blipFill>
+        <p:spPr>
+          <a:xfrm>
+            <a:off x="897486" y="1778654"/>
+            <a:ext cx="5155006" cy="3840480"/>
+          </a:xfrm>
+          <a:prstGeom prst="rect">
+            <a:avLst/>
+          </a:prstGeom>
+        </p:spPr>
+      </p:pic>
+      <p:pic>
+        <p:nvPicPr>
+          <p:cNvPr id="7" name="Picture 6" descr="A graph of a bus&#10;&#10;AI-generated content may be incorrect.">
+            <a:extLst>
+              <a:ext uri="{FF2B5EF4-FFF2-40B4-BE49-F238E27FC236}">
+                <a16:creationId xmlns:a16="http://schemas.microsoft.com/office/drawing/2014/main" id="{3C36CF7C-120E-2F40-292C-A4146273CC3D}"/>
+              </a:ext>
+            </a:extLst>
+          </p:cNvPr>
+          <p:cNvPicPr>
+            <a:picLocks noChangeAspect="1"/>
+          </p:cNvPicPr>
+          <p:nvPr/>
+        </p:nvPicPr>
+        <p:blipFill>
+          <a:blip r:embed="rId3"/>
+          <a:stretch>
+            <a:fillRect/>
+          </a:stretch>
+        </p:blipFill>
+        <p:spPr>
+          <a:xfrm>
+            <a:off x="6210925" y="1843394"/>
+            <a:ext cx="5559552" cy="3711000"/>
+          </a:xfrm>
+          <a:prstGeom prst="rect">
+            <a:avLst/>
+          </a:prstGeom>
+        </p:spPr>
+      </p:pic>
+    </p:spTree>
+    <p:extLst>
+      <p:ext uri="{BB962C8B-B14F-4D97-AF65-F5344CB8AC3E}">
+        <p14:creationId xmlns:p14="http://schemas.microsoft.com/office/powerpoint/2010/main" val="1777548272"/>
+      </p:ext>
+    </p:extLst>
+  </p:cSld>
+  <p:clrMapOvr>
+    <a:masterClrMapping/>
+  </p:clrMapOvr>
+</p:sld>
+</file>
+
+<file path=ppt/slides/slide23.xml><?xml version="1.0" encoding="utf-8"?>
+<p:sld xmlns:a="http://schemas.openxmlformats.org/drawingml/2006/main" xmlns:r="http://schemas.openxmlformats.org/officeDocument/2006/relationships" xmlns:p="http://schemas.openxmlformats.org/presentationml/2006/main">
+  <p:cSld>
+    <p:bg>
+      <p:bgPr>
+        <a:solidFill>
+          <a:schemeClr val="bg1"/>
+        </a:solidFill>
+        <a:effectLst/>
+      </p:bgPr>
+    </p:bg>
+    <p:spTree>
+      <p:nvGrpSpPr>
+        <p:cNvPr id="1" name=""/>
+        <p:cNvGrpSpPr/>
+        <p:nvPr/>
+      </p:nvGrpSpPr>
+      <p:grpSpPr>
+        <a:xfrm>
+          <a:off x="0" y="0"/>
+          <a:ext cx="0" cy="0"/>
+          <a:chOff x="0" y="0"/>
+          <a:chExt cx="0" cy="0"/>
+        </a:xfrm>
+      </p:grpSpPr>
+      <p:sp>
+        <p:nvSpPr>
+          <p:cNvPr id="12" name="Rectangle 11">
+            <a:extLst>
+              <a:ext uri="{FF2B5EF4-FFF2-40B4-BE49-F238E27FC236}">
+                <a16:creationId xmlns:a16="http://schemas.microsoft.com/office/drawing/2014/main" id="{35A92A98-187D-1D81-86FD-8D40CC69B622}"/>
+              </a:ext>
+              <a:ext uri="{C183D7F6-B498-43B3-948B-1728B52AA6E4}">
+                <adec:decorative xmlns:adec="http://schemas.microsoft.com/office/drawing/2017/decorative" val="1"/>
+              </a:ext>
+            </a:extLst>
+          </p:cNvPr>
+          <p:cNvSpPr>
+            <a:spLocks noGrp="1" noRot="1" noChangeAspect="1" noMove="1" noResize="1" noEditPoints="1" noAdjustHandles="1" noChangeArrowheads="1" noChangeShapeType="1" noTextEdit="1"/>
+          </p:cNvSpPr>
+          <p:nvPr>
+            <p:extLst>
+              <p:ext uri="{386F3935-93C4-4BCD-93E2-E3B085C9AB24}">
+                <p16:designElem xmlns:p16="http://schemas.microsoft.com/office/powerpoint/2015/main" val="1"/>
+              </p:ext>
+            </p:extLst>
+          </p:nvPr>
+        </p:nvSpPr>
+        <p:spPr>
+          <a:xfrm>
+            <a:off x="0" y="0"/>
+            <a:ext cx="12192000" cy="6858000"/>
+          </a:xfrm>
+          <a:prstGeom prst="rect">
+            <a:avLst/>
+          </a:prstGeom>
+          <a:solidFill>
+            <a:schemeClr val="bg1"/>
+          </a:solidFill>
+          <a:ln w="12700" cap="flat" cmpd="sng" algn="ctr">
+            <a:noFill/>
+            <a:prstDash val="solid"/>
+            <a:miter lim="800000"/>
+          </a:ln>
+          <a:effectLst/>
+          <a:extLst>
+            <a:ext uri="{91240B29-F687-4F45-9708-019B960494DF}">
+              <a14:hiddenLine xmlns:a14="http://schemas.microsoft.com/office/drawing/2010/main" w="12700" cap="flat" cmpd="sng" algn="ctr">
+                <a:solidFill>
+                  <a:schemeClr val="accent1">
+                    <a:shade val="15000"/>
+                  </a:schemeClr>
+                </a:solidFill>
+                <a:prstDash val="solid"/>
+                <a:miter lim="800000"/>
+              </a14:hiddenLine>
+            </a:ext>
+          </a:extLst>
+        </p:spPr>
+        <p:style>
+          <a:lnRef idx="2">
+            <a:schemeClr val="accent1">
+              <a:shade val="15000"/>
+            </a:schemeClr>
+          </a:lnRef>
+          <a:fillRef idx="1">
+            <a:schemeClr val="accent1"/>
+          </a:fillRef>
+          <a:effectRef idx="0">
+            <a:schemeClr val="accent1"/>
+          </a:effectRef>
+          <a:fontRef idx="minor">
+            <a:schemeClr val="lt1"/>
+          </a:fontRef>
+        </p:style>
+        <p:txBody>
+          <a:bodyPr rtlCol="0" anchor="ctr"/>
+          <a:lstStyle/>
+          <a:p>
+            <a:pPr algn="ctr"/>
+            <a:endParaRPr lang="en-US"/>
+          </a:p>
+        </p:txBody>
+      </p:sp>
+      <p:sp>
+        <p:nvSpPr>
+          <p:cNvPr id="2" name="Title 1">
+            <a:extLst>
+              <a:ext uri="{FF2B5EF4-FFF2-40B4-BE49-F238E27FC236}">
+                <a16:creationId xmlns:a16="http://schemas.microsoft.com/office/drawing/2014/main" id="{DCB9024E-4538-333B-6D7F-FA38561CC4D3}"/>
+              </a:ext>
+            </a:extLst>
+          </p:cNvPr>
+          <p:cNvSpPr>
+            <a:spLocks noGrp="1"/>
+          </p:cNvSpPr>
+          <p:nvPr>
+            <p:ph type="title"/>
+          </p:nvPr>
+        </p:nvSpPr>
+        <p:spPr>
+          <a:xfrm>
+            <a:off x="492940" y="473829"/>
+            <a:ext cx="11294162" cy="1170252"/>
+          </a:xfrm>
+        </p:spPr>
+        <p:txBody>
+          <a:bodyPr vert="horz" lIns="91440" tIns="45720" rIns="91440" bIns="45720" rtlCol="0" anchor="b">
+            <a:normAutofit/>
+          </a:bodyPr>
+          <a:lstStyle/>
+          <a:p>
+            <a:r>
+              <a:rPr lang="en-US" altLang="zh-CN" sz="4000"/>
+              <a:t>High Capacity vs bus</a:t>
+            </a:r>
+            <a:endParaRPr lang="en-US" sz="4000"/>
+          </a:p>
+        </p:txBody>
+      </p:sp>
+      <p:pic>
+        <p:nvPicPr>
+          <p:cNvPr id="7" name="Picture 6" descr="A graph of different colored squares&#10;&#10;AI-generated content may be incorrect.">
+            <a:extLst>
+              <a:ext uri="{FF2B5EF4-FFF2-40B4-BE49-F238E27FC236}">
+                <a16:creationId xmlns:a16="http://schemas.microsoft.com/office/drawing/2014/main" id="{D43D5536-23EF-42C1-2920-8AE4A21318AA}"/>
+              </a:ext>
+            </a:extLst>
+          </p:cNvPr>
+          <p:cNvPicPr>
+            <a:picLocks noChangeAspect="1"/>
+          </p:cNvPicPr>
+          <p:nvPr/>
+        </p:nvPicPr>
+        <p:blipFill>
+          <a:blip r:embed="rId2"/>
+          <a:stretch>
+            <a:fillRect/>
+          </a:stretch>
+        </p:blipFill>
+        <p:spPr>
+          <a:xfrm>
+            <a:off x="6447171" y="2117910"/>
+            <a:ext cx="5559552" cy="3711000"/>
+          </a:xfrm>
+          <a:prstGeom prst="rect">
+            <a:avLst/>
+          </a:prstGeom>
+        </p:spPr>
+      </p:pic>
+      <p:pic>
+        <p:nvPicPr>
+          <p:cNvPr id="5" name="Picture 4" descr="A graph showing different colored squares&#10;&#10;AI-generated content may be incorrect.">
+            <a:extLst>
+              <a:ext uri="{FF2B5EF4-FFF2-40B4-BE49-F238E27FC236}">
+                <a16:creationId xmlns:a16="http://schemas.microsoft.com/office/drawing/2014/main" id="{BBD18066-1200-341F-7066-61082D823F39}"/>
+              </a:ext>
+            </a:extLst>
+          </p:cNvPr>
+          <p:cNvPicPr>
+            <a:picLocks noChangeAspect="1"/>
+          </p:cNvPicPr>
+          <p:nvPr/>
+        </p:nvPicPr>
+        <p:blipFill>
+          <a:blip r:embed="rId3"/>
+          <a:stretch>
+            <a:fillRect/>
+          </a:stretch>
+        </p:blipFill>
+        <p:spPr>
+          <a:xfrm>
+            <a:off x="492940" y="2117910"/>
+            <a:ext cx="5559552" cy="3182843"/>
+          </a:xfrm>
+          <a:prstGeom prst="rect">
+            <a:avLst/>
+          </a:prstGeom>
+        </p:spPr>
+      </p:pic>
+    </p:spTree>
+    <p:extLst>
+      <p:ext uri="{BB962C8B-B14F-4D97-AF65-F5344CB8AC3E}">
+        <p14:creationId xmlns:p14="http://schemas.microsoft.com/office/powerpoint/2010/main" val="452256707"/>
       </p:ext>
     </p:extLst>
   </p:cSld>

</xml_diff>

<commit_message>
finished out mex city
</commit_message>
<xml_diff>
--- a/doc/mexico city trip compa.pptx
+++ b/doc/mexico city trip compa.pptx
@@ -5,7 +5,7 @@
     <p:sldMasterId id="2147483673" r:id="rId1"/>
   </p:sldMasterIdLst>
   <p:notesMasterIdLst>
-    <p:notesMasterId r:id="rId25"/>
+    <p:notesMasterId r:id="rId31"/>
   </p:notesMasterIdLst>
   <p:sldIdLst>
     <p:sldId id="256" r:id="rId2"/>
@@ -31,6 +31,12 @@
     <p:sldId id="276" r:id="rId22"/>
     <p:sldId id="277" r:id="rId23"/>
     <p:sldId id="278" r:id="rId24"/>
+    <p:sldId id="279" r:id="rId25"/>
+    <p:sldId id="280" r:id="rId26"/>
+    <p:sldId id="281" r:id="rId27"/>
+    <p:sldId id="282" r:id="rId28"/>
+    <p:sldId id="283" r:id="rId29"/>
+    <p:sldId id="284" r:id="rId30"/>
   </p:sldIdLst>
   <p:sldSz cx="12192000" cy="6858000"/>
   <p:notesSz cx="6858000" cy="9144000"/>
@@ -6059,10 +6065,10 @@
           <a:lstStyle/>
           <a:p>
             <a:r>
-              <a:rPr lang="en-US" altLang="zh-CN" sz="4000"/>
+              <a:rPr lang="en-US" altLang="zh-CN" sz="4000" dirty="0"/>
               <a:t>2007 vs 2017 single-trip distribution</a:t>
             </a:r>
-            <a:endParaRPr lang="en-US" sz="4000"/>
+            <a:endParaRPr lang="en-US" sz="4000" dirty="0"/>
           </a:p>
         </p:txBody>
       </p:sp>
@@ -7101,6 +7107,1340 @@
     <p:extLst>
       <p:ext uri="{BB962C8B-B14F-4D97-AF65-F5344CB8AC3E}">
         <p14:creationId xmlns:p14="http://schemas.microsoft.com/office/powerpoint/2010/main" val="452256707"/>
+      </p:ext>
+    </p:extLst>
+  </p:cSld>
+  <p:clrMapOvr>
+    <a:masterClrMapping/>
+  </p:clrMapOvr>
+</p:sld>
+</file>
+
+<file path=ppt/slides/slide24.xml><?xml version="1.0" encoding="utf-8"?>
+<p:sld xmlns:a="http://schemas.openxmlformats.org/drawingml/2006/main" xmlns:r="http://schemas.openxmlformats.org/officeDocument/2006/relationships" xmlns:p="http://schemas.openxmlformats.org/presentationml/2006/main">
+  <p:cSld>
+    <p:spTree>
+      <p:nvGrpSpPr>
+        <p:cNvPr id="1" name="">
+          <a:extLst>
+            <a:ext uri="{FF2B5EF4-FFF2-40B4-BE49-F238E27FC236}">
+              <a16:creationId xmlns:a16="http://schemas.microsoft.com/office/drawing/2014/main" id="{22694AD5-E6C9-E91C-C606-87FABD302048}"/>
+            </a:ext>
+          </a:extLst>
+        </p:cNvPr>
+        <p:cNvGrpSpPr/>
+        <p:nvPr/>
+      </p:nvGrpSpPr>
+      <p:grpSpPr>
+        <a:xfrm>
+          <a:off x="0" y="0"/>
+          <a:ext cx="0" cy="0"/>
+          <a:chOff x="0" y="0"/>
+          <a:chExt cx="0" cy="0"/>
+        </a:xfrm>
+      </p:grpSpPr>
+      <p:sp>
+        <p:nvSpPr>
+          <p:cNvPr id="2" name="Title 1">
+            <a:extLst>
+              <a:ext uri="{FF2B5EF4-FFF2-40B4-BE49-F238E27FC236}">
+                <a16:creationId xmlns:a16="http://schemas.microsoft.com/office/drawing/2014/main" id="{5DD6EE31-25BD-C550-5B51-76E9BD00E8C5}"/>
+              </a:ext>
+            </a:extLst>
+          </p:cNvPr>
+          <p:cNvSpPr>
+            <a:spLocks noGrp="1"/>
+          </p:cNvSpPr>
+          <p:nvPr>
+            <p:ph type="title"/>
+          </p:nvPr>
+        </p:nvSpPr>
+        <p:spPr>
+          <a:xfrm>
+            <a:off x="769211" y="2862871"/>
+            <a:ext cx="10653578" cy="1132258"/>
+          </a:xfrm>
+        </p:spPr>
+        <p:txBody>
+          <a:bodyPr/>
+          <a:lstStyle/>
+          <a:p>
+            <a:r>
+              <a:rPr lang="en-US" altLang="zh-CN" dirty="0"/>
+              <a:t>Mexico</a:t>
+            </a:r>
+            <a:r>
+              <a:rPr lang="zh-CN" altLang="en-US" dirty="0"/>
+              <a:t> </a:t>
+            </a:r>
+            <a:r>
+              <a:rPr lang="en-US" altLang="zh-CN" dirty="0"/>
+              <a:t>City</a:t>
+            </a:r>
+            <a:endParaRPr lang="en-US" dirty="0"/>
+          </a:p>
+        </p:txBody>
+      </p:sp>
+    </p:spTree>
+    <p:extLst>
+      <p:ext uri="{BB962C8B-B14F-4D97-AF65-F5344CB8AC3E}">
+        <p14:creationId xmlns:p14="http://schemas.microsoft.com/office/powerpoint/2010/main" val="673180828"/>
+      </p:ext>
+    </p:extLst>
+  </p:cSld>
+  <p:clrMapOvr>
+    <a:masterClrMapping/>
+  </p:clrMapOvr>
+</p:sld>
+</file>
+
+<file path=ppt/slides/slide25.xml><?xml version="1.0" encoding="utf-8"?>
+<p:sld xmlns:a="http://schemas.openxmlformats.org/drawingml/2006/main" xmlns:r="http://schemas.openxmlformats.org/officeDocument/2006/relationships" xmlns:p="http://schemas.openxmlformats.org/presentationml/2006/main">
+  <p:cSld>
+    <p:bg>
+      <p:bgPr>
+        <a:solidFill>
+          <a:schemeClr val="bg1"/>
+        </a:solidFill>
+        <a:effectLst/>
+      </p:bgPr>
+    </p:bg>
+    <p:spTree>
+      <p:nvGrpSpPr>
+        <p:cNvPr id="1" name=""/>
+        <p:cNvGrpSpPr/>
+        <p:nvPr/>
+      </p:nvGrpSpPr>
+      <p:grpSpPr>
+        <a:xfrm>
+          <a:off x="0" y="0"/>
+          <a:ext cx="0" cy="0"/>
+          <a:chOff x="0" y="0"/>
+          <a:chExt cx="0" cy="0"/>
+        </a:xfrm>
+      </p:grpSpPr>
+      <p:sp>
+        <p:nvSpPr>
+          <p:cNvPr id="12" name="Rectangle 11">
+            <a:extLst>
+              <a:ext uri="{FF2B5EF4-FFF2-40B4-BE49-F238E27FC236}">
+                <a16:creationId xmlns:a16="http://schemas.microsoft.com/office/drawing/2014/main" id="{35A92A98-187D-1D81-86FD-8D40CC69B622}"/>
+              </a:ext>
+              <a:ext uri="{C183D7F6-B498-43B3-948B-1728B52AA6E4}">
+                <adec:decorative xmlns:adec="http://schemas.microsoft.com/office/drawing/2017/decorative" val="1"/>
+              </a:ext>
+            </a:extLst>
+          </p:cNvPr>
+          <p:cNvSpPr>
+            <a:spLocks noGrp="1" noRot="1" noChangeAspect="1" noMove="1" noResize="1" noEditPoints="1" noAdjustHandles="1" noChangeArrowheads="1" noChangeShapeType="1" noTextEdit="1"/>
+          </p:cNvSpPr>
+          <p:nvPr>
+            <p:extLst>
+              <p:ext uri="{386F3935-93C4-4BCD-93E2-E3B085C9AB24}">
+                <p16:designElem xmlns:p16="http://schemas.microsoft.com/office/powerpoint/2015/main" val="1"/>
+              </p:ext>
+            </p:extLst>
+          </p:nvPr>
+        </p:nvSpPr>
+        <p:spPr>
+          <a:xfrm>
+            <a:off x="0" y="0"/>
+            <a:ext cx="12192000" cy="6858000"/>
+          </a:xfrm>
+          <a:prstGeom prst="rect">
+            <a:avLst/>
+          </a:prstGeom>
+          <a:solidFill>
+            <a:schemeClr val="bg1"/>
+          </a:solidFill>
+          <a:ln w="12700" cap="flat" cmpd="sng" algn="ctr">
+            <a:noFill/>
+            <a:prstDash val="solid"/>
+            <a:miter lim="800000"/>
+          </a:ln>
+          <a:effectLst/>
+          <a:extLst>
+            <a:ext uri="{91240B29-F687-4F45-9708-019B960494DF}">
+              <a14:hiddenLine xmlns:a14="http://schemas.microsoft.com/office/drawing/2010/main" w="12700" cap="flat" cmpd="sng" algn="ctr">
+                <a:solidFill>
+                  <a:schemeClr val="accent1">
+                    <a:shade val="15000"/>
+                  </a:schemeClr>
+                </a:solidFill>
+                <a:prstDash val="solid"/>
+                <a:miter lim="800000"/>
+              </a14:hiddenLine>
+            </a:ext>
+          </a:extLst>
+        </p:spPr>
+        <p:style>
+          <a:lnRef idx="2">
+            <a:schemeClr val="accent1">
+              <a:shade val="15000"/>
+            </a:schemeClr>
+          </a:lnRef>
+          <a:fillRef idx="1">
+            <a:schemeClr val="accent1"/>
+          </a:fillRef>
+          <a:effectRef idx="0">
+            <a:schemeClr val="accent1"/>
+          </a:effectRef>
+          <a:fontRef idx="minor">
+            <a:schemeClr val="lt1"/>
+          </a:fontRef>
+        </p:style>
+        <p:txBody>
+          <a:bodyPr rtlCol="0" anchor="ctr"/>
+          <a:lstStyle/>
+          <a:p>
+            <a:pPr algn="ctr"/>
+            <a:endParaRPr lang="en-US"/>
+          </a:p>
+        </p:txBody>
+      </p:sp>
+      <p:sp>
+        <p:nvSpPr>
+          <p:cNvPr id="2" name="Title 1">
+            <a:extLst>
+              <a:ext uri="{FF2B5EF4-FFF2-40B4-BE49-F238E27FC236}">
+                <a16:creationId xmlns:a16="http://schemas.microsoft.com/office/drawing/2014/main" id="{0F0776D1-B2D1-DB15-5CD7-62BEBDC226F8}"/>
+              </a:ext>
+            </a:extLst>
+          </p:cNvPr>
+          <p:cNvSpPr>
+            <a:spLocks noGrp="1"/>
+          </p:cNvSpPr>
+          <p:nvPr>
+            <p:ph type="title"/>
+          </p:nvPr>
+        </p:nvSpPr>
+        <p:spPr>
+          <a:xfrm>
+            <a:off x="492940" y="473829"/>
+            <a:ext cx="11294162" cy="1170252"/>
+          </a:xfrm>
+        </p:spPr>
+        <p:txBody>
+          <a:bodyPr vert="horz" lIns="91440" tIns="45720" rIns="91440" bIns="45720" rtlCol="0" anchor="b">
+            <a:normAutofit/>
+          </a:bodyPr>
+          <a:lstStyle/>
+          <a:p>
+            <a:r>
+              <a:rPr lang="en-US" altLang="zh-CN" sz="4000"/>
+              <a:t>2007 vs 2017 single-trip distribution</a:t>
+            </a:r>
+            <a:endParaRPr lang="en-US" sz="4000"/>
+          </a:p>
+        </p:txBody>
+      </p:sp>
+      <p:pic>
+        <p:nvPicPr>
+          <p:cNvPr id="7" name="Picture 6" descr="A graph of a number of trips&#10;&#10;AI-generated content may be incorrect.">
+            <a:extLst>
+              <a:ext uri="{FF2B5EF4-FFF2-40B4-BE49-F238E27FC236}">
+                <a16:creationId xmlns:a16="http://schemas.microsoft.com/office/drawing/2014/main" id="{29A409EC-4FCB-31F7-3A1F-B75BC246AB04}"/>
+              </a:ext>
+            </a:extLst>
+          </p:cNvPr>
+          <p:cNvPicPr>
+            <a:picLocks noChangeAspect="1"/>
+          </p:cNvPicPr>
+          <p:nvPr/>
+        </p:nvPicPr>
+        <p:blipFill>
+          <a:blip r:embed="rId2"/>
+          <a:stretch>
+            <a:fillRect/>
+          </a:stretch>
+        </p:blipFill>
+        <p:spPr>
+          <a:xfrm>
+            <a:off x="6632096" y="1757389"/>
+            <a:ext cx="5155006" cy="3840480"/>
+          </a:xfrm>
+          <a:prstGeom prst="rect">
+            <a:avLst/>
+          </a:prstGeom>
+        </p:spPr>
+      </p:pic>
+      <p:pic>
+        <p:nvPicPr>
+          <p:cNvPr id="5" name="Picture 4" descr="A graph with different colored bars&#10;&#10;AI-generated content may be incorrect.">
+            <a:extLst>
+              <a:ext uri="{FF2B5EF4-FFF2-40B4-BE49-F238E27FC236}">
+                <a16:creationId xmlns:a16="http://schemas.microsoft.com/office/drawing/2014/main" id="{6B1A0D74-8C0C-DED1-E7C0-575FB98933B5}"/>
+              </a:ext>
+            </a:extLst>
+          </p:cNvPr>
+          <p:cNvPicPr>
+            <a:picLocks noChangeAspect="1"/>
+          </p:cNvPicPr>
+          <p:nvPr/>
+        </p:nvPicPr>
+        <p:blipFill>
+          <a:blip r:embed="rId3"/>
+          <a:stretch>
+            <a:fillRect/>
+          </a:stretch>
+        </p:blipFill>
+        <p:spPr>
+          <a:xfrm>
+            <a:off x="940994" y="1757389"/>
+            <a:ext cx="5155006" cy="3840480"/>
+          </a:xfrm>
+          <a:prstGeom prst="rect">
+            <a:avLst/>
+          </a:prstGeom>
+        </p:spPr>
+      </p:pic>
+    </p:spTree>
+    <p:extLst>
+      <p:ext uri="{BB962C8B-B14F-4D97-AF65-F5344CB8AC3E}">
+        <p14:creationId xmlns:p14="http://schemas.microsoft.com/office/powerpoint/2010/main" val="1893491060"/>
+      </p:ext>
+    </p:extLst>
+  </p:cSld>
+  <p:clrMapOvr>
+    <a:masterClrMapping/>
+  </p:clrMapOvr>
+</p:sld>
+</file>
+
+<file path=ppt/slides/slide26.xml><?xml version="1.0" encoding="utf-8"?>
+<p:sld xmlns:a="http://schemas.openxmlformats.org/drawingml/2006/main" xmlns:r="http://schemas.openxmlformats.org/officeDocument/2006/relationships" xmlns:p="http://schemas.openxmlformats.org/presentationml/2006/main">
+  <p:cSld>
+    <p:bg>
+      <p:bgPr>
+        <a:solidFill>
+          <a:schemeClr val="bg1"/>
+        </a:solidFill>
+        <a:effectLst/>
+      </p:bgPr>
+    </p:bg>
+    <p:spTree>
+      <p:nvGrpSpPr>
+        <p:cNvPr id="1" name=""/>
+        <p:cNvGrpSpPr/>
+        <p:nvPr/>
+      </p:nvGrpSpPr>
+      <p:grpSpPr>
+        <a:xfrm>
+          <a:off x="0" y="0"/>
+          <a:ext cx="0" cy="0"/>
+          <a:chOff x="0" y="0"/>
+          <a:chExt cx="0" cy="0"/>
+        </a:xfrm>
+      </p:grpSpPr>
+      <p:sp>
+        <p:nvSpPr>
+          <p:cNvPr id="12" name="Rectangle 11">
+            <a:extLst>
+              <a:ext uri="{FF2B5EF4-FFF2-40B4-BE49-F238E27FC236}">
+                <a16:creationId xmlns:a16="http://schemas.microsoft.com/office/drawing/2014/main" id="{03F5E461-A014-9B58-DDA5-B3796228EC51}"/>
+              </a:ext>
+              <a:ext uri="{C183D7F6-B498-43B3-948B-1728B52AA6E4}">
+                <adec:decorative xmlns:adec="http://schemas.microsoft.com/office/drawing/2017/decorative" val="1"/>
+              </a:ext>
+            </a:extLst>
+          </p:cNvPr>
+          <p:cNvSpPr>
+            <a:spLocks noGrp="1" noRot="1" noChangeAspect="1" noMove="1" noResize="1" noEditPoints="1" noAdjustHandles="1" noChangeArrowheads="1" noChangeShapeType="1" noTextEdit="1"/>
+          </p:cNvSpPr>
+          <p:nvPr>
+            <p:extLst>
+              <p:ext uri="{386F3935-93C4-4BCD-93E2-E3B085C9AB24}">
+                <p16:designElem xmlns:p16="http://schemas.microsoft.com/office/powerpoint/2015/main" val="1"/>
+              </p:ext>
+            </p:extLst>
+          </p:nvPr>
+        </p:nvSpPr>
+        <p:spPr>
+          <a:xfrm>
+            <a:off x="0" y="0"/>
+            <a:ext cx="12192000" cy="6858000"/>
+          </a:xfrm>
+          <a:prstGeom prst="rect">
+            <a:avLst/>
+          </a:prstGeom>
+          <a:solidFill>
+            <a:schemeClr val="bg1"/>
+          </a:solidFill>
+          <a:ln w="12700" cap="flat" cmpd="sng" algn="ctr">
+            <a:noFill/>
+            <a:prstDash val="solid"/>
+            <a:miter lim="800000"/>
+          </a:ln>
+          <a:effectLst/>
+          <a:extLst>
+            <a:ext uri="{91240B29-F687-4F45-9708-019B960494DF}">
+              <a14:hiddenLine xmlns:a14="http://schemas.microsoft.com/office/drawing/2010/main" w="12700" cap="flat" cmpd="sng" algn="ctr">
+                <a:solidFill>
+                  <a:schemeClr val="accent1">
+                    <a:shade val="15000"/>
+                  </a:schemeClr>
+                </a:solidFill>
+                <a:prstDash val="solid"/>
+                <a:miter lim="800000"/>
+              </a14:hiddenLine>
+            </a:ext>
+          </a:extLst>
+        </p:spPr>
+        <p:style>
+          <a:lnRef idx="2">
+            <a:schemeClr val="accent1">
+              <a:shade val="15000"/>
+            </a:schemeClr>
+          </a:lnRef>
+          <a:fillRef idx="1">
+            <a:schemeClr val="accent1"/>
+          </a:fillRef>
+          <a:effectRef idx="0">
+            <a:schemeClr val="accent1"/>
+          </a:effectRef>
+          <a:fontRef idx="minor">
+            <a:schemeClr val="lt1"/>
+          </a:fontRef>
+        </p:style>
+        <p:txBody>
+          <a:bodyPr rtlCol="0" anchor="ctr"/>
+          <a:lstStyle/>
+          <a:p>
+            <a:pPr algn="ctr"/>
+            <a:endParaRPr lang="en-US"/>
+          </a:p>
+        </p:txBody>
+      </p:sp>
+      <p:sp>
+        <p:nvSpPr>
+          <p:cNvPr id="2" name="Title 1">
+            <a:extLst>
+              <a:ext uri="{FF2B5EF4-FFF2-40B4-BE49-F238E27FC236}">
+                <a16:creationId xmlns:a16="http://schemas.microsoft.com/office/drawing/2014/main" id="{D5B30961-76DB-AFA1-86EA-E262F9F90876}"/>
+              </a:ext>
+            </a:extLst>
+          </p:cNvPr>
+          <p:cNvSpPr>
+            <a:spLocks noGrp="1"/>
+          </p:cNvSpPr>
+          <p:nvPr>
+            <p:ph type="title"/>
+          </p:nvPr>
+        </p:nvSpPr>
+        <p:spPr>
+          <a:xfrm>
+            <a:off x="1742209" y="323326"/>
+            <a:ext cx="8728364" cy="1132829"/>
+          </a:xfrm>
+        </p:spPr>
+        <p:txBody>
+          <a:bodyPr vert="horz" lIns="91440" tIns="45720" rIns="91440" bIns="45720" rtlCol="0" anchor="b">
+            <a:normAutofit/>
+          </a:bodyPr>
+          <a:lstStyle/>
+          <a:p>
+            <a:pPr algn="ctr"/>
+            <a:r>
+              <a:rPr lang="en-US" sz="4400"/>
+              <a:t>Metro</a:t>
+            </a:r>
+            <a:r>
+              <a:rPr lang="en-US" altLang="zh-CN" sz="4400"/>
+              <a:t> multimodal trip</a:t>
+            </a:r>
+            <a:endParaRPr lang="en-US" sz="4400"/>
+          </a:p>
+        </p:txBody>
+      </p:sp>
+      <p:pic>
+        <p:nvPicPr>
+          <p:cNvPr id="5" name="Picture 4" descr="A graph of multicolored squares&#10;&#10;AI-generated content may be incorrect.">
+            <a:extLst>
+              <a:ext uri="{FF2B5EF4-FFF2-40B4-BE49-F238E27FC236}">
+                <a16:creationId xmlns:a16="http://schemas.microsoft.com/office/drawing/2014/main" id="{0D4D875A-36FD-B89E-8993-78D01513A4A6}"/>
+              </a:ext>
+            </a:extLst>
+          </p:cNvPr>
+          <p:cNvPicPr>
+            <a:picLocks noChangeAspect="1"/>
+          </p:cNvPicPr>
+          <p:nvPr/>
+        </p:nvPicPr>
+        <p:blipFill>
+          <a:blip r:embed="rId2"/>
+          <a:srcRect r="-3" b="7393"/>
+          <a:stretch>
+            <a:fillRect/>
+          </a:stretch>
+        </p:blipFill>
+        <p:spPr>
+          <a:xfrm>
+            <a:off x="25031" y="2169898"/>
+            <a:ext cx="6070969" cy="4188372"/>
+          </a:xfrm>
+          <a:prstGeom prst="rect">
+            <a:avLst/>
+          </a:prstGeom>
+        </p:spPr>
+      </p:pic>
+      <p:pic>
+        <p:nvPicPr>
+          <p:cNvPr id="7" name="Picture 6" descr="A graph with text and numbers&#10;&#10;AI-generated content may be incorrect.">
+            <a:extLst>
+              <a:ext uri="{FF2B5EF4-FFF2-40B4-BE49-F238E27FC236}">
+                <a16:creationId xmlns:a16="http://schemas.microsoft.com/office/drawing/2014/main" id="{1A54392B-FC57-D7CD-9975-E19C7F01D17F}"/>
+              </a:ext>
+            </a:extLst>
+          </p:cNvPr>
+          <p:cNvPicPr>
+            <a:picLocks noChangeAspect="1"/>
+          </p:cNvPicPr>
+          <p:nvPr/>
+        </p:nvPicPr>
+        <p:blipFill>
+          <a:blip r:embed="rId3"/>
+          <a:srcRect r="-2" b="7381"/>
+          <a:stretch>
+            <a:fillRect/>
+          </a:stretch>
+        </p:blipFill>
+        <p:spPr>
+          <a:xfrm>
+            <a:off x="6146895" y="2169898"/>
+            <a:ext cx="6070115" cy="4188372"/>
+          </a:xfrm>
+          <a:prstGeom prst="rect">
+            <a:avLst/>
+          </a:prstGeom>
+        </p:spPr>
+      </p:pic>
+    </p:spTree>
+    <p:extLst>
+      <p:ext uri="{BB962C8B-B14F-4D97-AF65-F5344CB8AC3E}">
+        <p14:creationId xmlns:p14="http://schemas.microsoft.com/office/powerpoint/2010/main" val="1731768043"/>
+      </p:ext>
+    </p:extLst>
+  </p:cSld>
+  <p:clrMapOvr>
+    <a:masterClrMapping/>
+  </p:clrMapOvr>
+  <p:timing>
+    <p:tnLst>
+      <p:par>
+        <p:cTn id="1" dur="indefinite" restart="never" nodeType="tmRoot">
+          <p:childTnLst>
+            <p:seq concurrent="1" nextAc="seek">
+              <p:cTn id="2" dur="indefinite" nodeType="mainSeq">
+                <p:childTnLst>
+                  <p:par>
+                    <p:cTn id="3" fill="hold">
+                      <p:stCondLst>
+                        <p:cond delay="indefinite"/>
+                        <p:cond evt="onBegin" delay="0">
+                          <p:tn val="2"/>
+                        </p:cond>
+                      </p:stCondLst>
+                      <p:childTnLst>
+                        <p:par>
+                          <p:cTn id="4" fill="hold">
+                            <p:stCondLst>
+                              <p:cond delay="0"/>
+                            </p:stCondLst>
+                            <p:childTnLst>
+                              <p:par>
+                                <p:cTn id="5" presetID="10" presetClass="entr" presetSubtype="0" fill="hold" grpId="0" nodeType="withEffect">
+                                  <p:stCondLst>
+                                    <p:cond delay="1000"/>
+                                  </p:stCondLst>
+                                  <p:iterate>
+                                    <p:tmPct val="10000"/>
+                                  </p:iterate>
+                                  <p:childTnLst>
+                                    <p:set>
+                                      <p:cBhvr>
+                                        <p:cTn id="6" dur="1" fill="hold">
+                                          <p:stCondLst>
+                                            <p:cond delay="0"/>
+                                          </p:stCondLst>
+                                        </p:cTn>
+                                        <p:tgtEl>
+                                          <p:spTgt spid="2"/>
+                                        </p:tgtEl>
+                                        <p:attrNameLst>
+                                          <p:attrName>style.visibility</p:attrName>
+                                        </p:attrNameLst>
+                                      </p:cBhvr>
+                                      <p:to>
+                                        <p:strVal val="visible"/>
+                                      </p:to>
+                                    </p:set>
+                                    <p:animEffect transition="in" filter="fade">
+                                      <p:cBhvr>
+                                        <p:cTn id="7" dur="700"/>
+                                        <p:tgtEl>
+                                          <p:spTgt spid="2"/>
+                                        </p:tgtEl>
+                                      </p:cBhvr>
+                                    </p:animEffect>
+                                  </p:childTnLst>
+                                </p:cTn>
+                              </p:par>
+                            </p:childTnLst>
+                          </p:cTn>
+                        </p:par>
+                      </p:childTnLst>
+                    </p:cTn>
+                  </p:par>
+                </p:childTnLst>
+              </p:cTn>
+              <p:prevCondLst>
+                <p:cond evt="onPrev" delay="0">
+                  <p:tgtEl>
+                    <p:sldTgt/>
+                  </p:tgtEl>
+                </p:cond>
+              </p:prevCondLst>
+              <p:nextCondLst>
+                <p:cond evt="onNext" delay="0">
+                  <p:tgtEl>
+                    <p:sldTgt/>
+                  </p:tgtEl>
+                </p:cond>
+              </p:nextCondLst>
+            </p:seq>
+          </p:childTnLst>
+        </p:cTn>
+      </p:par>
+    </p:tnLst>
+    <p:bldLst>
+      <p:bldP spid="2" grpId="0"/>
+    </p:bldLst>
+  </p:timing>
+</p:sld>
+</file>
+
+<file path=ppt/slides/slide27.xml><?xml version="1.0" encoding="utf-8"?>
+<p:sld xmlns:a="http://schemas.openxmlformats.org/drawingml/2006/main" xmlns:r="http://schemas.openxmlformats.org/officeDocument/2006/relationships" xmlns:p="http://schemas.openxmlformats.org/presentationml/2006/main">
+  <p:cSld>
+    <p:bg>
+      <p:bgPr>
+        <a:solidFill>
+          <a:schemeClr val="bg1"/>
+        </a:solidFill>
+        <a:effectLst/>
+      </p:bgPr>
+    </p:bg>
+    <p:spTree>
+      <p:nvGrpSpPr>
+        <p:cNvPr id="1" name=""/>
+        <p:cNvGrpSpPr/>
+        <p:nvPr/>
+      </p:nvGrpSpPr>
+      <p:grpSpPr>
+        <a:xfrm>
+          <a:off x="0" y="0"/>
+          <a:ext cx="0" cy="0"/>
+          <a:chOff x="0" y="0"/>
+          <a:chExt cx="0" cy="0"/>
+        </a:xfrm>
+      </p:grpSpPr>
+      <p:sp>
+        <p:nvSpPr>
+          <p:cNvPr id="12" name="Rectangle 11">
+            <a:extLst>
+              <a:ext uri="{FF2B5EF4-FFF2-40B4-BE49-F238E27FC236}">
+                <a16:creationId xmlns:a16="http://schemas.microsoft.com/office/drawing/2014/main" id="{03F5E461-A014-9B58-DDA5-B3796228EC51}"/>
+              </a:ext>
+              <a:ext uri="{C183D7F6-B498-43B3-948B-1728B52AA6E4}">
+                <adec:decorative xmlns:adec="http://schemas.microsoft.com/office/drawing/2017/decorative" val="1"/>
+              </a:ext>
+            </a:extLst>
+          </p:cNvPr>
+          <p:cNvSpPr>
+            <a:spLocks noGrp="1" noRot="1" noChangeAspect="1" noMove="1" noResize="1" noEditPoints="1" noAdjustHandles="1" noChangeArrowheads="1" noChangeShapeType="1" noTextEdit="1"/>
+          </p:cNvSpPr>
+          <p:nvPr>
+            <p:extLst>
+              <p:ext uri="{386F3935-93C4-4BCD-93E2-E3B085C9AB24}">
+                <p16:designElem xmlns:p16="http://schemas.microsoft.com/office/powerpoint/2015/main" val="1"/>
+              </p:ext>
+            </p:extLst>
+          </p:nvPr>
+        </p:nvSpPr>
+        <p:spPr>
+          <a:xfrm>
+            <a:off x="0" y="0"/>
+            <a:ext cx="12192000" cy="6858000"/>
+          </a:xfrm>
+          <a:prstGeom prst="rect">
+            <a:avLst/>
+          </a:prstGeom>
+          <a:solidFill>
+            <a:schemeClr val="bg1"/>
+          </a:solidFill>
+          <a:ln w="12700" cap="flat" cmpd="sng" algn="ctr">
+            <a:noFill/>
+            <a:prstDash val="solid"/>
+            <a:miter lim="800000"/>
+          </a:ln>
+          <a:effectLst/>
+          <a:extLst>
+            <a:ext uri="{91240B29-F687-4F45-9708-019B960494DF}">
+              <a14:hiddenLine xmlns:a14="http://schemas.microsoft.com/office/drawing/2010/main" w="12700" cap="flat" cmpd="sng" algn="ctr">
+                <a:solidFill>
+                  <a:schemeClr val="accent1">
+                    <a:shade val="15000"/>
+                  </a:schemeClr>
+                </a:solidFill>
+                <a:prstDash val="solid"/>
+                <a:miter lim="800000"/>
+              </a14:hiddenLine>
+            </a:ext>
+          </a:extLst>
+        </p:spPr>
+        <p:style>
+          <a:lnRef idx="2">
+            <a:schemeClr val="accent1">
+              <a:shade val="15000"/>
+            </a:schemeClr>
+          </a:lnRef>
+          <a:fillRef idx="1">
+            <a:schemeClr val="accent1"/>
+          </a:fillRef>
+          <a:effectRef idx="0">
+            <a:schemeClr val="accent1"/>
+          </a:effectRef>
+          <a:fontRef idx="minor">
+            <a:schemeClr val="lt1"/>
+          </a:fontRef>
+        </p:style>
+        <p:txBody>
+          <a:bodyPr rtlCol="0" anchor="ctr"/>
+          <a:lstStyle/>
+          <a:p>
+            <a:pPr algn="ctr"/>
+            <a:endParaRPr lang="en-US"/>
+          </a:p>
+        </p:txBody>
+      </p:sp>
+      <p:sp>
+        <p:nvSpPr>
+          <p:cNvPr id="2" name="Title 1">
+            <a:extLst>
+              <a:ext uri="{FF2B5EF4-FFF2-40B4-BE49-F238E27FC236}">
+                <a16:creationId xmlns:a16="http://schemas.microsoft.com/office/drawing/2014/main" id="{EBE8B099-957E-8C59-606A-6B5187D5BFE3}"/>
+              </a:ext>
+            </a:extLst>
+          </p:cNvPr>
+          <p:cNvSpPr>
+            <a:spLocks noGrp="1"/>
+          </p:cNvSpPr>
+          <p:nvPr>
+            <p:ph type="title"/>
+          </p:nvPr>
+        </p:nvSpPr>
+        <p:spPr>
+          <a:xfrm>
+            <a:off x="1742209" y="323326"/>
+            <a:ext cx="8728364" cy="1132829"/>
+          </a:xfrm>
+        </p:spPr>
+        <p:txBody>
+          <a:bodyPr vert="horz" lIns="91440" tIns="45720" rIns="91440" bIns="45720" rtlCol="0" anchor="b">
+            <a:normAutofit/>
+          </a:bodyPr>
+          <a:lstStyle/>
+          <a:p>
+            <a:pPr algn="ctr"/>
+            <a:r>
+              <a:rPr lang="en-US" sz="4400"/>
+              <a:t>BRT</a:t>
+            </a:r>
+          </a:p>
+        </p:txBody>
+      </p:sp>
+      <p:pic>
+        <p:nvPicPr>
+          <p:cNvPr id="7" name="Picture 6" descr="A graph with a bar chart&#10;&#10;AI-generated content may be incorrect.">
+            <a:extLst>
+              <a:ext uri="{FF2B5EF4-FFF2-40B4-BE49-F238E27FC236}">
+                <a16:creationId xmlns:a16="http://schemas.microsoft.com/office/drawing/2014/main" id="{1119016F-4534-85D5-B20D-9BE07324DD19}"/>
+              </a:ext>
+            </a:extLst>
+          </p:cNvPr>
+          <p:cNvPicPr>
+            <a:picLocks noChangeAspect="1"/>
+          </p:cNvPicPr>
+          <p:nvPr/>
+        </p:nvPicPr>
+        <p:blipFill>
+          <a:blip r:embed="rId2"/>
+          <a:srcRect r="-3" b="7393"/>
+          <a:stretch>
+            <a:fillRect/>
+          </a:stretch>
+        </p:blipFill>
+        <p:spPr>
+          <a:xfrm>
+            <a:off x="21" y="1779481"/>
+            <a:ext cx="6070969" cy="4188372"/>
+          </a:xfrm>
+          <a:prstGeom prst="rect">
+            <a:avLst/>
+          </a:prstGeom>
+        </p:spPr>
+      </p:pic>
+      <p:pic>
+        <p:nvPicPr>
+          <p:cNvPr id="5" name="Picture 4" descr="A graph with a bar chart&#10;&#10;AI-generated content may be incorrect.">
+            <a:extLst>
+              <a:ext uri="{FF2B5EF4-FFF2-40B4-BE49-F238E27FC236}">
+                <a16:creationId xmlns:a16="http://schemas.microsoft.com/office/drawing/2014/main" id="{A14345A9-180E-529F-B5F1-DBA99E2E9651}"/>
+              </a:ext>
+            </a:extLst>
+          </p:cNvPr>
+          <p:cNvPicPr>
+            <a:picLocks noChangeAspect="1"/>
+          </p:cNvPicPr>
+          <p:nvPr/>
+        </p:nvPicPr>
+        <p:blipFill>
+          <a:blip r:embed="rId3"/>
+          <a:srcRect r="-2" b="7381"/>
+          <a:stretch>
+            <a:fillRect/>
+          </a:stretch>
+        </p:blipFill>
+        <p:spPr>
+          <a:xfrm>
+            <a:off x="6121885" y="1779481"/>
+            <a:ext cx="6070115" cy="4188372"/>
+          </a:xfrm>
+          <a:prstGeom prst="rect">
+            <a:avLst/>
+          </a:prstGeom>
+        </p:spPr>
+      </p:pic>
+    </p:spTree>
+    <p:extLst>
+      <p:ext uri="{BB962C8B-B14F-4D97-AF65-F5344CB8AC3E}">
+        <p14:creationId xmlns:p14="http://schemas.microsoft.com/office/powerpoint/2010/main" val="706208705"/>
+      </p:ext>
+    </p:extLst>
+  </p:cSld>
+  <p:clrMapOvr>
+    <a:masterClrMapping/>
+  </p:clrMapOvr>
+  <p:timing>
+    <p:tnLst>
+      <p:par>
+        <p:cTn id="1" dur="indefinite" restart="never" nodeType="tmRoot">
+          <p:childTnLst>
+            <p:seq concurrent="1" nextAc="seek">
+              <p:cTn id="2" dur="indefinite" nodeType="mainSeq">
+                <p:childTnLst>
+                  <p:par>
+                    <p:cTn id="3" fill="hold">
+                      <p:stCondLst>
+                        <p:cond delay="indefinite"/>
+                        <p:cond evt="onBegin" delay="0">
+                          <p:tn val="2"/>
+                        </p:cond>
+                      </p:stCondLst>
+                      <p:childTnLst>
+                        <p:par>
+                          <p:cTn id="4" fill="hold">
+                            <p:stCondLst>
+                              <p:cond delay="0"/>
+                            </p:stCondLst>
+                            <p:childTnLst>
+                              <p:par>
+                                <p:cTn id="5" presetID="10" presetClass="entr" presetSubtype="0" fill="hold" grpId="0" nodeType="withEffect">
+                                  <p:stCondLst>
+                                    <p:cond delay="1000"/>
+                                  </p:stCondLst>
+                                  <p:iterate>
+                                    <p:tmPct val="10000"/>
+                                  </p:iterate>
+                                  <p:childTnLst>
+                                    <p:set>
+                                      <p:cBhvr>
+                                        <p:cTn id="6" dur="1" fill="hold">
+                                          <p:stCondLst>
+                                            <p:cond delay="0"/>
+                                          </p:stCondLst>
+                                        </p:cTn>
+                                        <p:tgtEl>
+                                          <p:spTgt spid="2"/>
+                                        </p:tgtEl>
+                                        <p:attrNameLst>
+                                          <p:attrName>style.visibility</p:attrName>
+                                        </p:attrNameLst>
+                                      </p:cBhvr>
+                                      <p:to>
+                                        <p:strVal val="visible"/>
+                                      </p:to>
+                                    </p:set>
+                                    <p:animEffect transition="in" filter="fade">
+                                      <p:cBhvr>
+                                        <p:cTn id="7" dur="700"/>
+                                        <p:tgtEl>
+                                          <p:spTgt spid="2"/>
+                                        </p:tgtEl>
+                                      </p:cBhvr>
+                                    </p:animEffect>
+                                  </p:childTnLst>
+                                </p:cTn>
+                              </p:par>
+                            </p:childTnLst>
+                          </p:cTn>
+                        </p:par>
+                      </p:childTnLst>
+                    </p:cTn>
+                  </p:par>
+                </p:childTnLst>
+              </p:cTn>
+              <p:prevCondLst>
+                <p:cond evt="onPrev" delay="0">
+                  <p:tgtEl>
+                    <p:sldTgt/>
+                  </p:tgtEl>
+                </p:cond>
+              </p:prevCondLst>
+              <p:nextCondLst>
+                <p:cond evt="onNext" delay="0">
+                  <p:tgtEl>
+                    <p:sldTgt/>
+                  </p:tgtEl>
+                </p:cond>
+              </p:nextCondLst>
+            </p:seq>
+          </p:childTnLst>
+        </p:cTn>
+      </p:par>
+    </p:tnLst>
+    <p:bldLst>
+      <p:bldP spid="2" grpId="0"/>
+    </p:bldLst>
+  </p:timing>
+</p:sld>
+</file>
+
+<file path=ppt/slides/slide28.xml><?xml version="1.0" encoding="utf-8"?>
+<p:sld xmlns:a="http://schemas.openxmlformats.org/drawingml/2006/main" xmlns:r="http://schemas.openxmlformats.org/officeDocument/2006/relationships" xmlns:p="http://schemas.openxmlformats.org/presentationml/2006/main">
+  <p:cSld>
+    <p:bg>
+      <p:bgPr>
+        <a:solidFill>
+          <a:schemeClr val="bg1"/>
+        </a:solidFill>
+        <a:effectLst/>
+      </p:bgPr>
+    </p:bg>
+    <p:spTree>
+      <p:nvGrpSpPr>
+        <p:cNvPr id="1" name=""/>
+        <p:cNvGrpSpPr/>
+        <p:nvPr/>
+      </p:nvGrpSpPr>
+      <p:grpSpPr>
+        <a:xfrm>
+          <a:off x="0" y="0"/>
+          <a:ext cx="0" cy="0"/>
+          <a:chOff x="0" y="0"/>
+          <a:chExt cx="0" cy="0"/>
+        </a:xfrm>
+      </p:grpSpPr>
+      <p:sp>
+        <p:nvSpPr>
+          <p:cNvPr id="12" name="Rectangle 11">
+            <a:extLst>
+              <a:ext uri="{FF2B5EF4-FFF2-40B4-BE49-F238E27FC236}">
+                <a16:creationId xmlns:a16="http://schemas.microsoft.com/office/drawing/2014/main" id="{35A92A98-187D-1D81-86FD-8D40CC69B622}"/>
+              </a:ext>
+              <a:ext uri="{C183D7F6-B498-43B3-948B-1728B52AA6E4}">
+                <adec:decorative xmlns:adec="http://schemas.microsoft.com/office/drawing/2017/decorative" val="1"/>
+              </a:ext>
+            </a:extLst>
+          </p:cNvPr>
+          <p:cNvSpPr>
+            <a:spLocks noGrp="1" noRot="1" noChangeAspect="1" noMove="1" noResize="1" noEditPoints="1" noAdjustHandles="1" noChangeArrowheads="1" noChangeShapeType="1" noTextEdit="1"/>
+          </p:cNvSpPr>
+          <p:nvPr>
+            <p:extLst>
+              <p:ext uri="{386F3935-93C4-4BCD-93E2-E3B085C9AB24}">
+                <p16:designElem xmlns:p16="http://schemas.microsoft.com/office/powerpoint/2015/main" val="1"/>
+              </p:ext>
+            </p:extLst>
+          </p:nvPr>
+        </p:nvSpPr>
+        <p:spPr>
+          <a:xfrm>
+            <a:off x="0" y="0"/>
+            <a:ext cx="12192000" cy="6858000"/>
+          </a:xfrm>
+          <a:prstGeom prst="rect">
+            <a:avLst/>
+          </a:prstGeom>
+          <a:solidFill>
+            <a:schemeClr val="bg1"/>
+          </a:solidFill>
+          <a:ln w="12700" cap="flat" cmpd="sng" algn="ctr">
+            <a:noFill/>
+            <a:prstDash val="solid"/>
+            <a:miter lim="800000"/>
+          </a:ln>
+          <a:effectLst/>
+          <a:extLst>
+            <a:ext uri="{91240B29-F687-4F45-9708-019B960494DF}">
+              <a14:hiddenLine xmlns:a14="http://schemas.microsoft.com/office/drawing/2010/main" w="12700" cap="flat" cmpd="sng" algn="ctr">
+                <a:solidFill>
+                  <a:schemeClr val="accent1">
+                    <a:shade val="15000"/>
+                  </a:schemeClr>
+                </a:solidFill>
+                <a:prstDash val="solid"/>
+                <a:miter lim="800000"/>
+              </a14:hiddenLine>
+            </a:ext>
+          </a:extLst>
+        </p:spPr>
+        <p:style>
+          <a:lnRef idx="2">
+            <a:schemeClr val="accent1">
+              <a:shade val="15000"/>
+            </a:schemeClr>
+          </a:lnRef>
+          <a:fillRef idx="1">
+            <a:schemeClr val="accent1"/>
+          </a:fillRef>
+          <a:effectRef idx="0">
+            <a:schemeClr val="accent1"/>
+          </a:effectRef>
+          <a:fontRef idx="minor">
+            <a:schemeClr val="lt1"/>
+          </a:fontRef>
+        </p:style>
+        <p:txBody>
+          <a:bodyPr rtlCol="0" anchor="ctr"/>
+          <a:lstStyle/>
+          <a:p>
+            <a:pPr algn="ctr"/>
+            <a:endParaRPr lang="en-US"/>
+          </a:p>
+        </p:txBody>
+      </p:sp>
+      <p:sp>
+        <p:nvSpPr>
+          <p:cNvPr id="2" name="Title 1">
+            <a:extLst>
+              <a:ext uri="{FF2B5EF4-FFF2-40B4-BE49-F238E27FC236}">
+                <a16:creationId xmlns:a16="http://schemas.microsoft.com/office/drawing/2014/main" id="{4E282686-D0FB-F873-4D58-1348852AB0E6}"/>
+              </a:ext>
+            </a:extLst>
+          </p:cNvPr>
+          <p:cNvSpPr>
+            <a:spLocks noGrp="1"/>
+          </p:cNvSpPr>
+          <p:nvPr>
+            <p:ph type="title"/>
+          </p:nvPr>
+        </p:nvSpPr>
+        <p:spPr>
+          <a:xfrm>
+            <a:off x="492940" y="473829"/>
+            <a:ext cx="11294162" cy="1170252"/>
+          </a:xfrm>
+        </p:spPr>
+        <p:txBody>
+          <a:bodyPr vert="horz" lIns="91440" tIns="45720" rIns="91440" bIns="45720" rtlCol="0" anchor="b">
+            <a:normAutofit/>
+          </a:bodyPr>
+          <a:lstStyle/>
+          <a:p>
+            <a:r>
+              <a:rPr lang="en-US" sz="4000"/>
+              <a:t>Bus</a:t>
+            </a:r>
+          </a:p>
+        </p:txBody>
+      </p:sp>
+      <p:pic>
+        <p:nvPicPr>
+          <p:cNvPr id="5" name="Picture 4" descr="A graph showing a number of buses&#10;&#10;AI-generated content may be incorrect.">
+            <a:extLst>
+              <a:ext uri="{FF2B5EF4-FFF2-40B4-BE49-F238E27FC236}">
+                <a16:creationId xmlns:a16="http://schemas.microsoft.com/office/drawing/2014/main" id="{541F6D25-8297-1A56-9DEA-478FBC2954BD}"/>
+              </a:ext>
+            </a:extLst>
+          </p:cNvPr>
+          <p:cNvPicPr>
+            <a:picLocks noChangeAspect="1"/>
+          </p:cNvPicPr>
+          <p:nvPr/>
+        </p:nvPicPr>
+        <p:blipFill>
+          <a:blip r:embed="rId2"/>
+          <a:stretch>
+            <a:fillRect/>
+          </a:stretch>
+        </p:blipFill>
+        <p:spPr>
+          <a:xfrm>
+            <a:off x="897486" y="1778654"/>
+            <a:ext cx="5155006" cy="3840480"/>
+          </a:xfrm>
+          <a:prstGeom prst="rect">
+            <a:avLst/>
+          </a:prstGeom>
+        </p:spPr>
+      </p:pic>
+      <p:pic>
+        <p:nvPicPr>
+          <p:cNvPr id="7" name="Picture 6" descr="A graph of a bus trip&#10;&#10;AI-generated content may be incorrect.">
+            <a:extLst>
+              <a:ext uri="{FF2B5EF4-FFF2-40B4-BE49-F238E27FC236}">
+                <a16:creationId xmlns:a16="http://schemas.microsoft.com/office/drawing/2014/main" id="{8A06D6CF-7679-29D9-7A38-54A00D4DC7E9}"/>
+              </a:ext>
+            </a:extLst>
+          </p:cNvPr>
+          <p:cNvPicPr>
+            <a:picLocks noChangeAspect="1"/>
+          </p:cNvPicPr>
+          <p:nvPr/>
+        </p:nvPicPr>
+        <p:blipFill>
+          <a:blip r:embed="rId3"/>
+          <a:stretch>
+            <a:fillRect/>
+          </a:stretch>
+        </p:blipFill>
+        <p:spPr>
+          <a:xfrm>
+            <a:off x="6210925" y="2107472"/>
+            <a:ext cx="5559552" cy="3182843"/>
+          </a:xfrm>
+          <a:prstGeom prst="rect">
+            <a:avLst/>
+          </a:prstGeom>
+        </p:spPr>
+      </p:pic>
+    </p:spTree>
+    <p:extLst>
+      <p:ext uri="{BB962C8B-B14F-4D97-AF65-F5344CB8AC3E}">
+        <p14:creationId xmlns:p14="http://schemas.microsoft.com/office/powerpoint/2010/main" val="698936527"/>
+      </p:ext>
+    </p:extLst>
+  </p:cSld>
+  <p:clrMapOvr>
+    <a:masterClrMapping/>
+  </p:clrMapOvr>
+</p:sld>
+</file>
+
+<file path=ppt/slides/slide29.xml><?xml version="1.0" encoding="utf-8"?>
+<p:sld xmlns:a="http://schemas.openxmlformats.org/drawingml/2006/main" xmlns:r="http://schemas.openxmlformats.org/officeDocument/2006/relationships" xmlns:p="http://schemas.openxmlformats.org/presentationml/2006/main">
+  <p:cSld>
+    <p:bg>
+      <p:bgPr>
+        <a:solidFill>
+          <a:schemeClr val="bg1"/>
+        </a:solidFill>
+        <a:effectLst/>
+      </p:bgPr>
+    </p:bg>
+    <p:spTree>
+      <p:nvGrpSpPr>
+        <p:cNvPr id="1" name=""/>
+        <p:cNvGrpSpPr/>
+        <p:nvPr/>
+      </p:nvGrpSpPr>
+      <p:grpSpPr>
+        <a:xfrm>
+          <a:off x="0" y="0"/>
+          <a:ext cx="0" cy="0"/>
+          <a:chOff x="0" y="0"/>
+          <a:chExt cx="0" cy="0"/>
+        </a:xfrm>
+      </p:grpSpPr>
+      <p:sp>
+        <p:nvSpPr>
+          <p:cNvPr id="12" name="Rectangle 11">
+            <a:extLst>
+              <a:ext uri="{FF2B5EF4-FFF2-40B4-BE49-F238E27FC236}">
+                <a16:creationId xmlns:a16="http://schemas.microsoft.com/office/drawing/2014/main" id="{35A92A98-187D-1D81-86FD-8D40CC69B622}"/>
+              </a:ext>
+              <a:ext uri="{C183D7F6-B498-43B3-948B-1728B52AA6E4}">
+                <adec:decorative xmlns:adec="http://schemas.microsoft.com/office/drawing/2017/decorative" val="1"/>
+              </a:ext>
+            </a:extLst>
+          </p:cNvPr>
+          <p:cNvSpPr>
+            <a:spLocks noGrp="1" noRot="1" noChangeAspect="1" noMove="1" noResize="1" noEditPoints="1" noAdjustHandles="1" noChangeArrowheads="1" noChangeShapeType="1" noTextEdit="1"/>
+          </p:cNvSpPr>
+          <p:nvPr>
+            <p:extLst>
+              <p:ext uri="{386F3935-93C4-4BCD-93E2-E3B085C9AB24}">
+                <p16:designElem xmlns:p16="http://schemas.microsoft.com/office/powerpoint/2015/main" val="1"/>
+              </p:ext>
+            </p:extLst>
+          </p:nvPr>
+        </p:nvSpPr>
+        <p:spPr>
+          <a:xfrm>
+            <a:off x="0" y="0"/>
+            <a:ext cx="12192000" cy="6858000"/>
+          </a:xfrm>
+          <a:prstGeom prst="rect">
+            <a:avLst/>
+          </a:prstGeom>
+          <a:solidFill>
+            <a:schemeClr val="bg1"/>
+          </a:solidFill>
+          <a:ln w="12700" cap="flat" cmpd="sng" algn="ctr">
+            <a:noFill/>
+            <a:prstDash val="solid"/>
+            <a:miter lim="800000"/>
+          </a:ln>
+          <a:effectLst/>
+          <a:extLst>
+            <a:ext uri="{91240B29-F687-4F45-9708-019B960494DF}">
+              <a14:hiddenLine xmlns:a14="http://schemas.microsoft.com/office/drawing/2010/main" w="12700" cap="flat" cmpd="sng" algn="ctr">
+                <a:solidFill>
+                  <a:schemeClr val="accent1">
+                    <a:shade val="15000"/>
+                  </a:schemeClr>
+                </a:solidFill>
+                <a:prstDash val="solid"/>
+                <a:miter lim="800000"/>
+              </a14:hiddenLine>
+            </a:ext>
+          </a:extLst>
+        </p:spPr>
+        <p:style>
+          <a:lnRef idx="2">
+            <a:schemeClr val="accent1">
+              <a:shade val="15000"/>
+            </a:schemeClr>
+          </a:lnRef>
+          <a:fillRef idx="1">
+            <a:schemeClr val="accent1"/>
+          </a:fillRef>
+          <a:effectRef idx="0">
+            <a:schemeClr val="accent1"/>
+          </a:effectRef>
+          <a:fontRef idx="minor">
+            <a:schemeClr val="lt1"/>
+          </a:fontRef>
+        </p:style>
+        <p:txBody>
+          <a:bodyPr rtlCol="0" anchor="ctr"/>
+          <a:lstStyle/>
+          <a:p>
+            <a:pPr algn="ctr"/>
+            <a:endParaRPr lang="en-US"/>
+          </a:p>
+        </p:txBody>
+      </p:sp>
+      <p:sp>
+        <p:nvSpPr>
+          <p:cNvPr id="2" name="Title 1">
+            <a:extLst>
+              <a:ext uri="{FF2B5EF4-FFF2-40B4-BE49-F238E27FC236}">
+                <a16:creationId xmlns:a16="http://schemas.microsoft.com/office/drawing/2014/main" id="{71882AC5-9139-1831-D7BC-27B6BB5E0F9E}"/>
+              </a:ext>
+            </a:extLst>
+          </p:cNvPr>
+          <p:cNvSpPr>
+            <a:spLocks noGrp="1"/>
+          </p:cNvSpPr>
+          <p:nvPr>
+            <p:ph type="title"/>
+          </p:nvPr>
+        </p:nvSpPr>
+        <p:spPr>
+          <a:xfrm>
+            <a:off x="492940" y="473829"/>
+            <a:ext cx="11294162" cy="1170252"/>
+          </a:xfrm>
+        </p:spPr>
+        <p:txBody>
+          <a:bodyPr vert="horz" lIns="91440" tIns="45720" rIns="91440" bIns="45720" rtlCol="0" anchor="b">
+            <a:normAutofit/>
+          </a:bodyPr>
+          <a:lstStyle/>
+          <a:p>
+            <a:r>
+              <a:rPr lang="en-US" sz="4000"/>
+              <a:t>High Capacity</a:t>
+            </a:r>
+          </a:p>
+        </p:txBody>
+      </p:sp>
+      <p:pic>
+        <p:nvPicPr>
+          <p:cNvPr id="7" name="Picture 6" descr="A graph with different colored squares&#10;&#10;AI-generated content may be incorrect.">
+            <a:extLst>
+              <a:ext uri="{FF2B5EF4-FFF2-40B4-BE49-F238E27FC236}">
+                <a16:creationId xmlns:a16="http://schemas.microsoft.com/office/drawing/2014/main" id="{A0578224-7814-277E-7A9B-8871D70D4F28}"/>
+              </a:ext>
+            </a:extLst>
+          </p:cNvPr>
+          <p:cNvPicPr>
+            <a:picLocks noChangeAspect="1"/>
+          </p:cNvPicPr>
+          <p:nvPr/>
+        </p:nvPicPr>
+        <p:blipFill>
+          <a:blip r:embed="rId2"/>
+          <a:stretch>
+            <a:fillRect/>
+          </a:stretch>
+        </p:blipFill>
+        <p:spPr>
+          <a:xfrm>
+            <a:off x="6294890" y="1832761"/>
+            <a:ext cx="5559552" cy="3711000"/>
+          </a:xfrm>
+          <a:prstGeom prst="rect">
+            <a:avLst/>
+          </a:prstGeom>
+        </p:spPr>
+      </p:pic>
+      <p:pic>
+        <p:nvPicPr>
+          <p:cNvPr id="5" name="Picture 4" descr="A graph of different colored squares&#10;&#10;AI-generated content may be incorrect.">
+            <a:extLst>
+              <a:ext uri="{FF2B5EF4-FFF2-40B4-BE49-F238E27FC236}">
+                <a16:creationId xmlns:a16="http://schemas.microsoft.com/office/drawing/2014/main" id="{2B980DDC-0E8C-EBC2-4BCB-F617F99ABDAF}"/>
+              </a:ext>
+            </a:extLst>
+          </p:cNvPr>
+          <p:cNvPicPr>
+            <a:picLocks noChangeAspect="1"/>
+          </p:cNvPicPr>
+          <p:nvPr/>
+        </p:nvPicPr>
+        <p:blipFill>
+          <a:blip r:embed="rId3"/>
+          <a:stretch>
+            <a:fillRect/>
+          </a:stretch>
+        </p:blipFill>
+        <p:spPr>
+          <a:xfrm>
+            <a:off x="400908" y="1832761"/>
+            <a:ext cx="5559552" cy="3711000"/>
+          </a:xfrm>
+          <a:prstGeom prst="rect">
+            <a:avLst/>
+          </a:prstGeom>
+        </p:spPr>
+      </p:pic>
+    </p:spTree>
+    <p:extLst>
+      <p:ext uri="{BB962C8B-B14F-4D97-AF65-F5344CB8AC3E}">
+        <p14:creationId xmlns:p14="http://schemas.microsoft.com/office/powerpoint/2010/main" val="86993735"/>
       </p:ext>
     </p:extLst>
   </p:cSld>

</xml_diff>